<commit_message>
docs: actualiza presentación de la defensa (ZonaProp Scraper.pptx)
</commit_message>
<xml_diff>
--- a/docs/ZonaProp Scraper.pptx
+++ b/docs/ZonaProp Scraper.pptx
@@ -4,6 +4,9 @@
   <p:sldMasterIdLst>
     <p:sldMasterId id="2147483648" r:id="rId1"/>
   </p:sldMasterIdLst>
+  <p:notesMasterIdLst>
+    <p:notesMasterId r:id="rId10"/>
+  </p:notesMasterIdLst>
   <p:sldIdLst>
     <p:sldId id="256" r:id="rId2"/>
     <p:sldId id="257" r:id="rId3"/>
@@ -14,16 +17,18 @@
     <p:sldId id="262" r:id="rId8"/>
     <p:sldId id="263" r:id="rId9"/>
   </p:sldIdLst>
-  <p:notesMasterIdLst>
-    <p:notesMasterId r:id="rId10"/>
-  </p:notesMasterIdLst>
   <p:sldSz cx="12192000" cy="6858000"/>
   <p:notesSz cx="6858000" cy="12192000"/>
   <p:embeddedFontLst>
     <p:embeddedFont>
-      <p:font typeface="Rubik" pitchFamily="34" charset="0"/>
-      <p:regular r:id="rId15"/>
-      <p:bold r:id="rId16"/>
+      <p:font typeface="IBM Plex Sans" panose="020B0503050203000203" pitchFamily="34" charset="0"/>
+      <p:regular r:id="rId11"/>
+      <p:bold r:id="rId12"/>
+    </p:embeddedFont>
+    <p:embeddedFont>
+      <p:font typeface="Rubik" panose="020B0604020202020204" charset="-79"/>
+      <p:regular r:id="rId13"/>
+      <p:bold r:id="rId14"/>
     </p:embeddedFont>
   </p:embeddedFontLst>
   <p:defaultTextStyle>
@@ -118,6 +123,11 @@
       </a:defRPr>
     </a:lvl9pPr>
   </p:defaultTextStyle>
+  <p:extLst>
+    <p:ext uri="{EFAFB233-063F-42B5-8137-9DF3F51BA10A}">
+      <p15:sldGuideLst xmlns:p15="http://schemas.microsoft.com/office/powerpoint/2012/main"/>
+    </p:ext>
+  </p:extLst>
 </p:presentation>
 </file>
 
@@ -143,234 +153,10 @@
           <a:chExt cx="0" cy="0"/>
         </a:xfrm>
       </p:grpSpPr>
-      <p:sp>
-        <p:nvSpPr>
-          <p:cNvPr id="2" name="Header Placeholder 1"/>
-          <p:cNvSpPr>
-            <a:spLocks noGrp="1"/>
-          </p:cNvSpPr>
-          <p:nvPr>
-            <p:ph type="hdr" sz="quarter"/>
-          </p:nvPr>
-        </p:nvSpPr>
-        <p:spPr>
-          <a:xfrm>
-            <a:off x="0" y="0"/>
-            <a:ext cx="2971800" cy="458788"/>
-          </a:xfrm>
-          <a:prstGeom prst="rect">
-            <a:avLst/>
-          </a:prstGeom>
-        </p:spPr>
-        <p:txBody>
-          <a:bodyPr vert="horz" lIns="91440" tIns="45720" rIns="91440" bIns="45720" rtlCol="0"/>
-          <a:lstStyle>
-            <a:lvl1pPr algn="l">
-              <a:defRPr sz="1200"/>
-            </a:lvl1pPr>
-          </a:lstStyle>
-          <a:p>
-            <a:endParaRPr lang="en-US"/>
-          </a:p>
-        </p:txBody>
-      </p:sp>
-      <p:sp>
-        <p:nvSpPr>
-          <p:cNvPr id="3" name="Date Placeholder 2"/>
-          <p:cNvSpPr>
-            <a:spLocks noGrp="1"/>
-          </p:cNvSpPr>
-          <p:nvPr>
-            <p:ph type="dt" idx="1"/>
-          </p:nvPr>
-        </p:nvSpPr>
-        <p:spPr>
-          <a:xfrm>
-            <a:off x="3884613" y="0"/>
-            <a:ext cx="2971800" cy="458788"/>
-          </a:xfrm>
-          <a:prstGeom prst="rect">
-            <a:avLst/>
-          </a:prstGeom>
-        </p:spPr>
-        <p:txBody>
-          <a:bodyPr vert="horz" lIns="91440" tIns="45720" rIns="91440" bIns="45720" rtlCol="0"/>
-          <a:lstStyle>
-            <a:lvl1pPr algn="r">
-              <a:defRPr sz="1200"/>
-            </a:lvl1pPr>
-          </a:lstStyle>
-          <a:p>
-            <a:fld id="{5282F153-3F37-0F45-9E97-73ACFA13230C}" type="datetimeFigureOut">
-              <a:rPr lang="en-US"/>
-              <a:t>7/23/19</a:t>
-            </a:fld>
-            <a:endParaRPr lang="en-US"/>
-          </a:p>
-        </p:txBody>
-      </p:sp>
-      <p:sp>
-        <p:nvSpPr>
-          <p:cNvPr id="4" name="Slide Image Placeholder 3"/>
-          <p:cNvSpPr>
-            <a:spLocks noGrp="1" noRot="1" noChangeAspect="1"/>
-          </p:cNvSpPr>
-          <p:nvPr>
-            <p:ph type="sldImg" idx="2"/>
-          </p:nvPr>
-        </p:nvSpPr>
-        <p:spPr>
-          <a:xfrm>
-            <a:off x="685800" y="1143000"/>
-            <a:ext cx="5486400" cy="3086100"/>
-          </a:xfrm>
-          <a:prstGeom prst="rect">
-            <a:avLst/>
-          </a:prstGeom>
-          <a:noFill/>
-          <a:ln w="12700">
-            <a:solidFill>
-              <a:prstClr val="black"/>
-            </a:solidFill>
-          </a:ln>
-        </p:spPr>
-        <p:txBody>
-          <a:bodyPr vert="horz" lIns="91440" tIns="45720" rIns="91440" bIns="45720" rtlCol="0" anchor="ctr"/>
-          <a:lstStyle/>
-          <a:p>
-            <a:endParaRPr lang="en-US"/>
-          </a:p>
-        </p:txBody>
-      </p:sp>
-      <p:sp>
-        <p:nvSpPr>
-          <p:cNvPr id="5" name="Notes Placeholder 4"/>
-          <p:cNvSpPr>
-            <a:spLocks noGrp="1"/>
-          </p:cNvSpPr>
-          <p:nvPr>
-            <p:ph type="body" sz="quarter" idx="3"/>
-          </p:nvPr>
-        </p:nvSpPr>
-        <p:spPr>
-          <a:xfrm>
-            <a:off x="685800" y="4400550"/>
-            <a:ext cx="5486400" cy="3600450"/>
-          </a:xfrm>
-          <a:prstGeom prst="rect">
-            <a:avLst/>
-          </a:prstGeom>
-        </p:spPr>
-        <p:txBody>
-          <a:bodyPr vert="horz" lIns="91440" tIns="45720" rIns="91440" bIns="45720" rtlCol="0"/>
-          <a:lstStyle/>
-          <a:p>
-            <a:pPr lvl="0"/>
-            <a:r>
-              <a:rPr lang="en-US"/>
-              <a:t>Click to edit Master text styles</a:t>
-            </a:r>
-          </a:p>
-          <a:p>
-            <a:pPr lvl="1"/>
-            <a:r>
-              <a:rPr lang="en-US"/>
-              <a:t>Second level</a:t>
-            </a:r>
-          </a:p>
-          <a:p>
-            <a:pPr lvl="2"/>
-            <a:r>
-              <a:rPr lang="en-US"/>
-              <a:t>Third level</a:t>
-            </a:r>
-          </a:p>
-          <a:p>
-            <a:pPr lvl="3"/>
-            <a:r>
-              <a:rPr lang="en-US"/>
-              <a:t>Fourth level</a:t>
-            </a:r>
-          </a:p>
-          <a:p>
-            <a:pPr lvl="4"/>
-            <a:r>
-              <a:rPr lang="en-US"/>
-              <a:t>Fifth level</a:t>
-            </a:r>
-          </a:p>
-        </p:txBody>
-      </p:sp>
-      <p:sp>
-        <p:nvSpPr>
-          <p:cNvPr id="6" name="Footer Placeholder 5"/>
-          <p:cNvSpPr>
-            <a:spLocks noGrp="1"/>
-          </p:cNvSpPr>
-          <p:nvPr>
-            <p:ph type="ftr" sz="quarter" idx="4"/>
-          </p:nvPr>
-        </p:nvSpPr>
-        <p:spPr>
-          <a:xfrm>
-            <a:off x="0" y="8685213"/>
-            <a:ext cx="2971800" cy="458787"/>
-          </a:xfrm>
-          <a:prstGeom prst="rect">
-            <a:avLst/>
-          </a:prstGeom>
-        </p:spPr>
-        <p:txBody>
-          <a:bodyPr vert="horz" lIns="91440" tIns="45720" rIns="91440" bIns="45720" rtlCol="0" anchor="b"/>
-          <a:lstStyle>
-            <a:lvl1pPr algn="l">
-              <a:defRPr sz="1200"/>
-            </a:lvl1pPr>
-          </a:lstStyle>
-          <a:p>
-            <a:endParaRPr lang="en-US"/>
-          </a:p>
-        </p:txBody>
-      </p:sp>
-      <p:sp>
-        <p:nvSpPr>
-          <p:cNvPr id="7" name="Slide Number Placeholder 6"/>
-          <p:cNvSpPr>
-            <a:spLocks noGrp="1"/>
-          </p:cNvSpPr>
-          <p:nvPr>
-            <p:ph type="sldNum" sz="quarter" idx="5"/>
-          </p:nvPr>
-        </p:nvSpPr>
-        <p:spPr>
-          <a:xfrm>
-            <a:off x="3884613" y="8685213"/>
-            <a:ext cx="2971800" cy="458787"/>
-          </a:xfrm>
-          <a:prstGeom prst="rect">
-            <a:avLst/>
-          </a:prstGeom>
-        </p:spPr>
-        <p:txBody>
-          <a:bodyPr vert="horz" lIns="91440" tIns="45720" rIns="91440" bIns="45720" rtlCol="0" anchor="b"/>
-          <a:lstStyle>
-            <a:lvl1pPr algn="r">
-              <a:defRPr sz="1200"/>
-            </a:lvl1pPr>
-          </a:lstStyle>
-          <a:p>
-            <a:fld id="{CE5E9CC1-C706-0F49-92D6-E571CC5EEA8F}" type="slidenum">
-              <a:rPr lang="en-US"/>
-              <a:t>‹#›</a:t>
-            </a:fld>
-            <a:endParaRPr lang="en-US"/>
-          </a:p>
-        </p:txBody>
-      </p:sp>
     </p:spTree>
     <p:extLst>
       <p:ext uri="{BB962C8B-B14F-4D97-AF65-F5344CB8AC3E}">
-        <p14:creationId xmlns:p14="http://schemas.microsoft.com/office/powerpoint/2010/main" val="1024086991"/>
+        <p14:creationId xmlns:p14="http://schemas.microsoft.com/office/powerpoint/2010/main" val="1361254573"/>
       </p:ext>
     </p:extLst>
   </p:cSld>
@@ -518,7 +304,6 @@
               <a:rPr lang="en-US" dirty="0"/>
               <a:t>Presentación del equipo. En 10 minutos recorremos el problema, cómo construimos el scraper, cómo validamos que los datos son confiables y qué modelo entrenamos con ellos.</a:t>
             </a:r>
-            <a:endParaRPr lang="en-US" dirty="0"/>
           </a:p>
         </p:txBody>
       </p:sp>
@@ -606,7 +391,6 @@
               <a:rPr lang="en-US" dirty="0"/>
               <a:t>La pregunta de negocio es el precio justo de un departamento. Pero para Web Mining lo central es que ese dato no existe como dataset: hay que construirlo desde la web. Por eso la mitad del trabajo es el scraper y la validación de lo que extrae; el modelo es el uso aguas abajo.</a:t>
             </a:r>
-            <a:endParaRPr lang="en-US" dirty="0"/>
           </a:p>
         </p:txBody>
       </p:sp>
@@ -694,7 +478,6 @@
               <a:rPr lang="en-US" dirty="0"/>
               <a:t>Todo corre local, sin servicios externos. Node se encarga del navegador y la extracción; Python del análisis. La interfaz deja lanzar el scraper, generar el reporte de calidad y entrenar o consultar el modelo. Que cada corrida quede guardada hace que los resultados sean reproducibles.</a:t>
             </a:r>
-            <a:endParaRPr lang="en-US" dirty="0"/>
           </a:p>
         </p:txBody>
       </p:sp>
@@ -782,7 +565,6 @@
               <a:rPr lang="en-US" dirty="0"/>
               <a:t>El scraper arma las búsquedas, pagina cada una y parsea cada tarjeta del listado. Cada aviso se escribe apenas se lee, así que cortar es seguro y la corrida siguiente retoma en la misma página. El ritmo es deliberadamente lento: es scraping académico, a ritmo humano, sin paralelizar.</a:t>
             </a:r>
-            <a:endParaRPr lang="en-US" dirty="0"/>
           </a:p>
         </p:txBody>
       </p:sp>
@@ -870,7 +652,6 @@
               <a:rPr lang="en-US" dirty="0"/>
               <a:t>Estas fueron las dificultades reales. Cloudflare obligó a usar un navegador real y no un cliente HTTP. ZonaProp corta la paginación, así que las búsquedas grandes se parten por precio. El sitio no da errores: redirige o repite páginas, y eso hay que detectarlo. Y como una corrida dura horas, todo se guarda a medida que se lee para poder retomar.</a:t>
             </a:r>
-            <a:endParaRPr lang="en-US" dirty="0"/>
           </a:p>
         </p:txBody>
       </p:sp>
@@ -958,7 +739,6 @@
               <a:rPr lang="en-US" dirty="0"/>
               <a:t>Para defender que el scraper funciona, separamos errores del scraper de errores de quien publica. Del lado del scraper: ningún aviso duplicado, todos los formatos correctos, los campos obligatorios completos, y lo extraído coincide con la URL, que es una fuente independiente del texto. Además el porcentaje de campos vacíos fue estable hora a hora, así que no cambió el HTML a mitad de camino. Del lado del origen, el reporte encuentra anunciantes que eligen pesos con montos en dólares o cargan valores de relleno. Todo esto está en la pantalla Calidad de datos y en el notebook 00.</a:t>
             </a:r>
-            <a:endParaRPr lang="en-US" dirty="0"/>
           </a:p>
         </p:txBody>
       </p:sp>
@@ -1046,7 +826,6 @@
               <a:rPr lang="en-US" dirty="0"/>
               <a:t>El modelo predice el logaritmo del precio por metro cuadrado con LightGBM. La decisión clave fue la validación: como la misma unidad aparece varias veces, un split aleatorio deja copias del mismo departamento en train y en test y el error sale optimista. Por eso el test se agrupa por unidad. El texto del aviso se usa sin montos, para que el modelo no lea el precio de la descripción.</a:t>
             </a:r>
-            <a:endParaRPr lang="en-US" dirty="0"/>
           </a:p>
         </p:txBody>
       </p:sp>
@@ -1134,7 +913,6 @@
               <a:rPr lang="en-US" dirty="0"/>
               <a:t>El modelo final se equivoca, en la mediana, un 9,9 % sobre departamentos que nunca vio, contra 18,5 % de la regla simple de mediana del barrio por metro cuadrado. La mitad de las predicciones cae dentro de más o menos 10 %, y el intervalo del 80 % está bien calibrado. La conclusión para Web Mining es que el mayor salto vino de entender los datos scrapeados: duplicados, fuga y limpieza. Límites: es una sola foto del mercado y son precios publicados, no de cierre.</a:t>
             </a:r>
-            <a:endParaRPr lang="en-US" dirty="0"/>
           </a:p>
         </p:txBody>
       </p:sp>
@@ -1212,6 +990,7 @@
         <a:solidFill>
           <a:srgbClr val="F7F6F2"/>
         </a:solidFill>
+        <a:effectLst/>
       </p:bgPr>
     </p:bg>
     <p:spTree>
@@ -1231,7 +1010,9 @@
       <p:sp>
         <p:nvSpPr>
           <p:cNvPr id="2" name="Title Placeholder 1"/>
-          <p:cNvSpPr/>
+          <p:cNvSpPr>
+            <a:spLocks noGrp="1"/>
+          </p:cNvSpPr>
           <p:nvPr>
             <p:ph type="title"/>
           </p:nvPr>
@@ -1250,7 +1031,7 @@
         <p:txBody>
           <a:bodyPr wrap="square" lIns="0" tIns="0" rIns="0" bIns="0" rtlCol="0" anchor="t"/>
           <a:lstStyle>
-            <a:lvl1pPr algn="l" indent="0" marL="0">
+            <a:lvl1pPr marL="0" indent="0" algn="l">
               <a:lnSpc>
                 <a:spcPct val="115000"/>
               </a:lnSpc>
@@ -1266,7 +1047,7 @@
             </a:lvl1pPr>
           </a:lstStyle>
           <a:p>
-            <a:pPr algn="l" indent="0" marL="0">
+            <a:pPr marL="0" indent="0" algn="l">
               <a:lnSpc>
                 <a:spcPct val="115000"/>
               </a:lnSpc>
@@ -1279,9 +1060,11 @@
       <p:sp>
         <p:nvSpPr>
           <p:cNvPr id="3" name="Text Placeholder 2"/>
-          <p:cNvSpPr/>
+          <p:cNvSpPr>
+            <a:spLocks noGrp="1"/>
+          </p:cNvSpPr>
           <p:nvPr>
-            <p:ph idx="101" type="body"/>
+            <p:ph type="body" idx="101"/>
           </p:nvPr>
         </p:nvSpPr>
         <p:spPr>
@@ -1298,7 +1081,7 @@
         <p:txBody>
           <a:bodyPr wrap="square" lIns="0" tIns="0" rIns="0" bIns="0" rtlCol="0" anchor="t"/>
           <a:lstStyle>
-            <a:lvl1pPr algn="l" indent="0" marL="0">
+            <a:lvl1pPr marL="0" indent="0" algn="l">
               <a:lnSpc>
                 <a:spcPct val="140000"/>
               </a:lnSpc>
@@ -1314,7 +1097,7 @@
             </a:lvl1pPr>
           </a:lstStyle>
           <a:p>
-            <a:pPr algn="l" indent="0" marL="0">
+            <a:pPr marL="0" indent="0" algn="l">
               <a:lnSpc>
                 <a:spcPct val="140000"/>
               </a:lnSpc>
@@ -1340,6 +1123,7 @@
         <a:solidFill>
           <a:srgbClr val="F7F6F2"/>
         </a:solidFill>
+        <a:effectLst/>
       </p:bgPr>
     </p:bg>
     <p:spTree>
@@ -1359,7 +1143,9 @@
       <p:sp>
         <p:nvSpPr>
           <p:cNvPr id="2" name="Title Placeholder 1"/>
-          <p:cNvSpPr/>
+          <p:cNvSpPr>
+            <a:spLocks noGrp="1"/>
+          </p:cNvSpPr>
           <p:nvPr>
             <p:ph type="title"/>
           </p:nvPr>
@@ -1378,7 +1164,7 @@
         <p:txBody>
           <a:bodyPr wrap="square" lIns="0" tIns="0" rIns="0" bIns="0" rtlCol="0" anchor="t"/>
           <a:lstStyle>
-            <a:lvl1pPr algn="l" indent="0" marL="0">
+            <a:lvl1pPr marL="0" indent="0" algn="l">
               <a:lnSpc>
                 <a:spcPct val="115000"/>
               </a:lnSpc>
@@ -1394,7 +1180,7 @@
             </a:lvl1pPr>
           </a:lstStyle>
           <a:p>
-            <a:pPr algn="l" indent="0" marL="0">
+            <a:pPr marL="0" indent="0" algn="l">
               <a:lnSpc>
                 <a:spcPct val="115000"/>
               </a:lnSpc>
@@ -1407,9 +1193,11 @@
       <p:sp>
         <p:nvSpPr>
           <p:cNvPr id="3" name="Text Placeholder 2"/>
-          <p:cNvSpPr/>
+          <p:cNvSpPr>
+            <a:spLocks noGrp="1"/>
+          </p:cNvSpPr>
           <p:nvPr>
-            <p:ph idx="101" type="body"/>
+            <p:ph type="body" idx="101"/>
           </p:nvPr>
         </p:nvSpPr>
         <p:spPr>
@@ -1426,7 +1214,7 @@
         <p:txBody>
           <a:bodyPr wrap="square" lIns="0" tIns="0" rIns="0" bIns="0" rtlCol="0" anchor="t"/>
           <a:lstStyle>
-            <a:lvl1pPr algn="l" indent="0" marL="0">
+            <a:lvl1pPr marL="0" indent="0" algn="l">
               <a:lnSpc>
                 <a:spcPct val="140000"/>
               </a:lnSpc>
@@ -1442,7 +1230,7 @@
             </a:lvl1pPr>
           </a:lstStyle>
           <a:p>
-            <a:pPr algn="l" indent="0" marL="0">
+            <a:pPr marL="0" indent="0" algn="l">
               <a:lnSpc>
                 <a:spcPct val="140000"/>
               </a:lnSpc>
@@ -1721,6 +1509,7 @@
         <a:solidFill>
           <a:srgbClr val="14213D"/>
         </a:solidFill>
+        <a:effectLst/>
       </p:bgPr>
     </p:bg>
     <p:spTree>
@@ -1756,6 +1545,13 @@
           </a:solidFill>
           <a:ln/>
         </p:spPr>
+        <p:txBody>
+          <a:bodyPr/>
+          <a:lstStyle/>
+          <a:p>
+            <a:endParaRPr lang="en-US"/>
+          </a:p>
+        </p:txBody>
       </p:sp>
       <p:sp>
         <p:nvSpPr>
@@ -1780,14 +1576,14 @@
           </a:bodyPr>
           <a:lstStyle/>
           <a:p>
-            <a:pPr algn="l" indent="0" marL="0">
+            <a:pPr marL="0" indent="0" algn="l">
               <a:lnSpc>
                 <a:spcPts val="1960"/>
               </a:lnSpc>
               <a:buNone/>
             </a:pPr>
             <a:r>
-              <a:rPr lang="en-US" sz="1400" b="1" spc="200" kern="0" dirty="0">
+              <a:rPr lang="en-US" sz="1400" b="1" kern="0" spc="200" dirty="0">
                 <a:solidFill>
                   <a:srgbClr val="F4A261"/>
                 </a:solidFill>
@@ -1804,7 +1600,9 @@
       <p:sp>
         <p:nvSpPr>
           <p:cNvPr id="4" name="Text 2"/>
-          <p:cNvSpPr/>
+          <p:cNvSpPr>
+            <a:spLocks noGrp="1"/>
+          </p:cNvSpPr>
           <p:nvPr>
             <p:ph type="title"/>
           </p:nvPr>
@@ -1826,7 +1624,7 @@
           </a:bodyPr>
           <a:lstStyle/>
           <a:p>
-            <a:pPr algn="l" indent="0" marL="0">
+            <a:pPr marL="0" indent="0" algn="l">
               <a:lnSpc>
                 <a:spcPts val="6300"/>
               </a:lnSpc>
@@ -1870,7 +1668,7 @@
           </a:bodyPr>
           <a:lstStyle/>
           <a:p>
-            <a:pPr algn="l" indent="0" marL="0">
+            <a:pPr marL="0" indent="0" algn="l">
               <a:lnSpc>
                 <a:spcPts val="2860"/>
               </a:lnSpc>
@@ -1899,8 +1697,8 @@
         </p:nvSpPr>
         <p:spPr>
           <a:xfrm>
-            <a:off x="812800" y="5796359"/>
-            <a:ext cx="1253371" cy="274241"/>
+            <a:off x="812800" y="5796360"/>
+            <a:ext cx="5984815" cy="319768"/>
           </a:xfrm>
           <a:prstGeom prst="rect">
             <a:avLst/>
@@ -1914,7 +1712,7 @@
           </a:bodyPr>
           <a:lstStyle/>
           <a:p>
-            <a:pPr algn="l" indent="0" marL="0">
+            <a:pPr marL="0" indent="0" algn="l">
               <a:lnSpc>
                 <a:spcPts val="1960"/>
               </a:lnSpc>
@@ -1929,43 +1727,10 @@
                 <a:ea typeface="IBM Plex Sans" pitchFamily="34" charset="-122"/>
                 <a:cs typeface="IBM Plex Sans" pitchFamily="34" charset="-120"/>
               </a:rPr>
-              <a:t>[Integrantes]</a:t>
-            </a:r>
-            <a:endParaRPr lang="en-US" sz="1400" dirty="0"/>
-          </a:p>
-        </p:txBody>
-      </p:sp>
-      <p:sp>
-        <p:nvSpPr>
-          <p:cNvPr id="7" name="Text 5"/>
-          <p:cNvSpPr/>
-          <p:nvPr/>
-        </p:nvSpPr>
-        <p:spPr>
-          <a:xfrm>
-            <a:off x="2263676" y="5796359"/>
-            <a:ext cx="2038112" cy="274241"/>
-          </a:xfrm>
-          <a:prstGeom prst="rect">
-            <a:avLst/>
-          </a:prstGeom>
-          <a:noFill/>
-          <a:ln/>
-        </p:spPr>
-        <p:txBody>
-          <a:bodyPr wrap="square" lIns="0" tIns="0" rIns="0" bIns="0" rtlCol="0" anchor="t">
-            <a:normAutofit/>
-          </a:bodyPr>
-          <a:lstStyle/>
-          <a:p>
-            <a:pPr algn="l" indent="0" marL="0">
-              <a:lnSpc>
-                <a:spcPts val="1960"/>
-              </a:lnSpc>
-              <a:buNone/>
-            </a:pPr>
-            <a:r>
-              <a:rPr lang="en-US" sz="1400" dirty="0">
+              <a:t>Corsetti, Ornela; Giorlando, Aimé; Rodriguez </a:t>
+            </a:r>
+            <a:r>
+              <a:rPr lang="en-US" sz="1400" dirty="0" err="1">
                 <a:solidFill>
                   <a:srgbClr val="C9D3E6"/>
                 </a:solidFill>
@@ -1973,7 +1738,18 @@
                 <a:ea typeface="IBM Plex Sans" pitchFamily="34" charset="-122"/>
                 <a:cs typeface="IBM Plex Sans" pitchFamily="34" charset="-120"/>
               </a:rPr>
-              <a:t>[Fecha de la defensa]</a:t>
+              <a:t>Zurro</a:t>
+            </a:r>
+            <a:r>
+              <a:rPr lang="en-US" sz="1400" dirty="0">
+                <a:solidFill>
+                  <a:srgbClr val="C9D3E6"/>
+                </a:solidFill>
+                <a:latin typeface="IBM Plex Sans" pitchFamily="34" charset="0"/>
+                <a:ea typeface="IBM Plex Sans" pitchFamily="34" charset="-122"/>
+                <a:cs typeface="IBM Plex Sans" pitchFamily="34" charset="-120"/>
+              </a:rPr>
+              <a:t>, Tomás; Horn, Nicolás</a:t>
             </a:r>
             <a:endParaRPr lang="en-US" sz="1400" dirty="0"/>
           </a:p>
@@ -1995,6 +1771,7 @@
         <a:solidFill>
           <a:srgbClr val="F7F6F2"/>
         </a:solidFill>
+        <a:effectLst/>
       </p:bgPr>
     </p:bg>
     <p:spTree>
@@ -2034,14 +1811,14 @@
           </a:bodyPr>
           <a:lstStyle/>
           <a:p>
-            <a:pPr algn="l" indent="0" marL="0">
+            <a:pPr marL="0" indent="0" algn="l">
               <a:lnSpc>
                 <a:spcPts val="1820"/>
               </a:lnSpc>
               <a:buNone/>
             </a:pPr>
             <a:r>
-              <a:rPr lang="en-US" sz="1300" b="1" spc="150" kern="0" dirty="0">
+              <a:rPr lang="en-US" sz="1300" b="1" kern="0" spc="150" dirty="0">
                 <a:solidFill>
                   <a:srgbClr val="B4470A"/>
                 </a:solidFill>
@@ -2058,7 +1835,9 @@
       <p:sp>
         <p:nvSpPr>
           <p:cNvPr id="3" name="Text 1"/>
-          <p:cNvSpPr/>
+          <p:cNvSpPr>
+            <a:spLocks noGrp="1"/>
+          </p:cNvSpPr>
           <p:nvPr>
             <p:ph type="title"/>
           </p:nvPr>
@@ -2080,7 +1859,7 @@
           </a:bodyPr>
           <a:lstStyle/>
           <a:p>
-            <a:pPr algn="l" indent="0" marL="0">
+            <a:pPr marL="0" indent="0" algn="l">
               <a:lnSpc>
                 <a:spcPts val="3960"/>
               </a:lnSpc>
@@ -2127,6 +1906,13 @@
             <a:prstDash val="solid"/>
           </a:ln>
         </p:spPr>
+        <p:txBody>
+          <a:bodyPr/>
+          <a:lstStyle/>
+          <a:p>
+            <a:endParaRPr lang="en-US"/>
+          </a:p>
+        </p:txBody>
       </p:sp>
       <p:sp>
         <p:nvSpPr>
@@ -2151,7 +1937,7 @@
           </a:bodyPr>
           <a:lstStyle/>
           <a:p>
-            <a:pPr algn="l" indent="0" marL="0">
+            <a:pPr marL="0" indent="0" algn="l">
               <a:lnSpc>
                 <a:spcPts val="2160"/>
               </a:lnSpc>
@@ -2195,7 +1981,7 @@
           </a:bodyPr>
           <a:lstStyle/>
           <a:p>
-            <a:pPr algn="l" indent="0" marL="0">
+            <a:pPr marL="0" indent="0" algn="l">
               <a:lnSpc>
                 <a:spcPts val="1960"/>
               </a:lnSpc>
@@ -2242,6 +2028,13 @@
             <a:prstDash val="solid"/>
           </a:ln>
         </p:spPr>
+        <p:txBody>
+          <a:bodyPr/>
+          <a:lstStyle/>
+          <a:p>
+            <a:endParaRPr lang="en-US"/>
+          </a:p>
+        </p:txBody>
       </p:sp>
       <p:sp>
         <p:nvSpPr>
@@ -2266,7 +2059,7 @@
           </a:bodyPr>
           <a:lstStyle/>
           <a:p>
-            <a:pPr algn="l" indent="0" marL="0">
+            <a:pPr marL="0" indent="0" algn="l">
               <a:lnSpc>
                 <a:spcPts val="2160"/>
               </a:lnSpc>
@@ -2310,7 +2103,7 @@
           </a:bodyPr>
           <a:lstStyle/>
           <a:p>
-            <a:pPr algn="l" indent="0" marL="0">
+            <a:pPr marL="0" indent="0" algn="l">
               <a:lnSpc>
                 <a:spcPts val="1960"/>
               </a:lnSpc>
@@ -2357,6 +2150,13 @@
             <a:prstDash val="solid"/>
           </a:ln>
         </p:spPr>
+        <p:txBody>
+          <a:bodyPr/>
+          <a:lstStyle/>
+          <a:p>
+            <a:endParaRPr lang="en-US"/>
+          </a:p>
+        </p:txBody>
       </p:sp>
       <p:sp>
         <p:nvSpPr>
@@ -2381,7 +2181,7 @@
           </a:bodyPr>
           <a:lstStyle/>
           <a:p>
-            <a:pPr algn="l" indent="0" marL="0">
+            <a:pPr marL="0" indent="0" algn="l">
               <a:lnSpc>
                 <a:spcPts val="2160"/>
               </a:lnSpc>
@@ -2425,7 +2225,7 @@
           </a:bodyPr>
           <a:lstStyle/>
           <a:p>
-            <a:pPr algn="l" indent="0" marL="0">
+            <a:pPr marL="0" indent="0" algn="l">
               <a:lnSpc>
                 <a:spcPts val="1960"/>
               </a:lnSpc>
@@ -2469,7 +2269,7 @@
           </a:bodyPr>
           <a:lstStyle/>
           <a:p>
-            <a:pPr algn="l" indent="0" marL="0">
+            <a:pPr marL="0" indent="0" algn="l">
               <a:lnSpc>
                 <a:spcPts val="1680"/>
               </a:lnSpc>
@@ -2506,6 +2306,7 @@
         <a:solidFill>
           <a:srgbClr val="F7F6F2"/>
         </a:solidFill>
+        <a:effectLst/>
       </p:bgPr>
     </p:bg>
     <p:spTree>
@@ -2545,14 +2346,14 @@
           </a:bodyPr>
           <a:lstStyle/>
           <a:p>
-            <a:pPr algn="l" indent="0" marL="0">
+            <a:pPr marL="0" indent="0" algn="l">
               <a:lnSpc>
                 <a:spcPts val="1820"/>
               </a:lnSpc>
               <a:buNone/>
             </a:pPr>
             <a:r>
-              <a:rPr lang="en-US" sz="1300" b="1" spc="150" kern="0" dirty="0">
+              <a:rPr lang="en-US" sz="1300" b="1" kern="0" spc="150" dirty="0">
                 <a:solidFill>
                   <a:srgbClr val="B4470A"/>
                 </a:solidFill>
@@ -2569,7 +2370,9 @@
       <p:sp>
         <p:nvSpPr>
           <p:cNvPr id="3" name="Text 1"/>
-          <p:cNvSpPr/>
+          <p:cNvSpPr>
+            <a:spLocks noGrp="1"/>
+          </p:cNvSpPr>
           <p:nvPr>
             <p:ph type="title"/>
           </p:nvPr>
@@ -2591,7 +2394,7 @@
           </a:bodyPr>
           <a:lstStyle/>
           <a:p>
-            <a:pPr algn="l" indent="0" marL="0">
+            <a:pPr marL="0" indent="0" algn="l">
               <a:lnSpc>
                 <a:spcPts val="3960"/>
               </a:lnSpc>
@@ -2633,6 +2436,13 @@
           </a:solidFill>
           <a:ln/>
         </p:spPr>
+        <p:txBody>
+          <a:bodyPr/>
+          <a:lstStyle/>
+          <a:p>
+            <a:endParaRPr lang="en-US"/>
+          </a:p>
+        </p:txBody>
       </p:sp>
       <p:sp>
         <p:nvSpPr>
@@ -2657,7 +2467,7 @@
           </a:bodyPr>
           <a:lstStyle/>
           <a:p>
-            <a:pPr algn="l" indent="0" marL="0">
+            <a:pPr marL="0" indent="0" algn="l">
               <a:lnSpc>
                 <a:spcPts val="1680"/>
               </a:lnSpc>
@@ -2701,7 +2511,7 @@
           </a:bodyPr>
           <a:lstStyle/>
           <a:p>
-            <a:pPr algn="l" indent="0" marL="0">
+            <a:pPr marL="0" indent="0" algn="l">
               <a:lnSpc>
                 <a:spcPts val="2040"/>
               </a:lnSpc>
@@ -2745,7 +2555,7 @@
           </a:bodyPr>
           <a:lstStyle/>
           <a:p>
-            <a:pPr algn="l" indent="0" marL="0">
+            <a:pPr marL="0" indent="0" algn="l">
               <a:lnSpc>
                 <a:spcPts val="1820"/>
               </a:lnSpc>
@@ -2768,15 +2578,15 @@
       </p:sp>
       <p:pic>
         <p:nvPicPr>
-          <p:cNvPr id="8" name="Image 0" descr="connector">    </p:cNvPr>
+          <p:cNvPr id="8" name="Image 0" descr="connector"/>
           <p:cNvPicPr>
             <a:picLocks noChangeAspect="1"/>
           </p:cNvPicPr>
           <p:nvPr/>
         </p:nvPicPr>
         <p:blipFill>
-          <a:blip r:embed="rId1"/>
-          <a:srcRect l="0" r="0" t="0" b="0"/>
+          <a:blip r:embed="rId3"/>
+          <a:srcRect/>
           <a:stretch/>
         </p:blipFill>
         <p:spPr>
@@ -2815,6 +2625,13 @@
             <a:prstDash val="solid"/>
           </a:ln>
         </p:spPr>
+        <p:txBody>
+          <a:bodyPr/>
+          <a:lstStyle/>
+          <a:p>
+            <a:endParaRPr lang="en-US"/>
+          </a:p>
+        </p:txBody>
       </p:sp>
       <p:sp>
         <p:nvSpPr>
@@ -2839,7 +2656,7 @@
           </a:bodyPr>
           <a:lstStyle/>
           <a:p>
-            <a:pPr algn="l" indent="0" marL="0">
+            <a:pPr marL="0" indent="0" algn="l">
               <a:lnSpc>
                 <a:spcPts val="1680"/>
               </a:lnSpc>
@@ -2883,7 +2700,7 @@
           </a:bodyPr>
           <a:lstStyle/>
           <a:p>
-            <a:pPr algn="l" indent="0" marL="0">
+            <a:pPr marL="0" indent="0" algn="l">
               <a:lnSpc>
                 <a:spcPts val="2040"/>
               </a:lnSpc>
@@ -2927,7 +2744,7 @@
           </a:bodyPr>
           <a:lstStyle/>
           <a:p>
-            <a:pPr algn="l" indent="0" marL="0">
+            <a:pPr marL="0" indent="0" algn="l">
               <a:lnSpc>
                 <a:spcPts val="1820"/>
               </a:lnSpc>
@@ -2950,15 +2767,15 @@
       </p:sp>
       <p:pic>
         <p:nvPicPr>
-          <p:cNvPr id="13" name="Image 1" descr="connector">    </p:cNvPr>
+          <p:cNvPr id="13" name="Image 1" descr="connector"/>
           <p:cNvPicPr>
             <a:picLocks noChangeAspect="1"/>
           </p:cNvPicPr>
           <p:nvPr/>
         </p:nvPicPr>
         <p:blipFill>
-          <a:blip r:embed="rId2"/>
-          <a:srcRect l="0" r="0" t="0" b="0"/>
+          <a:blip r:embed="rId3"/>
+          <a:srcRect/>
           <a:stretch/>
         </p:blipFill>
         <p:spPr>
@@ -2997,6 +2814,13 @@
             <a:prstDash val="solid"/>
           </a:ln>
         </p:spPr>
+        <p:txBody>
+          <a:bodyPr/>
+          <a:lstStyle/>
+          <a:p>
+            <a:endParaRPr lang="en-US"/>
+          </a:p>
+        </p:txBody>
       </p:sp>
       <p:sp>
         <p:nvSpPr>
@@ -3021,7 +2845,7 @@
           </a:bodyPr>
           <a:lstStyle/>
           <a:p>
-            <a:pPr algn="l" indent="0" marL="0">
+            <a:pPr marL="0" indent="0" algn="l">
               <a:lnSpc>
                 <a:spcPts val="1680"/>
               </a:lnSpc>
@@ -3065,7 +2889,7 @@
           </a:bodyPr>
           <a:lstStyle/>
           <a:p>
-            <a:pPr algn="l" indent="0" marL="0">
+            <a:pPr marL="0" indent="0" algn="l">
               <a:lnSpc>
                 <a:spcPts val="2040"/>
               </a:lnSpc>
@@ -3109,7 +2933,7 @@
           </a:bodyPr>
           <a:lstStyle/>
           <a:p>
-            <a:pPr algn="l" indent="0" marL="0">
+            <a:pPr marL="0" indent="0" algn="l">
               <a:lnSpc>
                 <a:spcPts val="1820"/>
               </a:lnSpc>
@@ -3132,7 +2956,7 @@
       </p:sp>
       <p:pic>
         <p:nvPicPr>
-          <p:cNvPr id="18" name="Image 2" descr="connector">    </p:cNvPr>
+          <p:cNvPr id="18" name="Image 2" descr="connector"/>
           <p:cNvPicPr>
             <a:picLocks noChangeAspect="1"/>
           </p:cNvPicPr>
@@ -3140,7 +2964,7 @@
         </p:nvPicPr>
         <p:blipFill>
           <a:blip r:embed="rId3"/>
-          <a:srcRect l="0" r="0" t="0" b="0"/>
+          <a:srcRect/>
           <a:stretch/>
         </p:blipFill>
         <p:spPr>
@@ -3179,6 +3003,13 @@
             <a:prstDash val="solid"/>
           </a:ln>
         </p:spPr>
+        <p:txBody>
+          <a:bodyPr/>
+          <a:lstStyle/>
+          <a:p>
+            <a:endParaRPr lang="en-US"/>
+          </a:p>
+        </p:txBody>
       </p:sp>
       <p:sp>
         <p:nvSpPr>
@@ -3203,7 +3034,7 @@
           </a:bodyPr>
           <a:lstStyle/>
           <a:p>
-            <a:pPr algn="l" indent="0" marL="0">
+            <a:pPr marL="0" indent="0" algn="l">
               <a:lnSpc>
                 <a:spcPts val="1680"/>
               </a:lnSpc>
@@ -3247,7 +3078,7 @@
           </a:bodyPr>
           <a:lstStyle/>
           <a:p>
-            <a:pPr algn="l" indent="0" marL="0">
+            <a:pPr marL="0" indent="0" algn="l">
               <a:lnSpc>
                 <a:spcPts val="2040"/>
               </a:lnSpc>
@@ -3291,7 +3122,7 @@
           </a:bodyPr>
           <a:lstStyle/>
           <a:p>
-            <a:pPr algn="l" indent="0" marL="0">
+            <a:pPr marL="0" indent="0" algn="l">
               <a:lnSpc>
                 <a:spcPts val="1820"/>
               </a:lnSpc>
@@ -3335,7 +3166,7 @@
           </a:bodyPr>
           <a:lstStyle/>
           <a:p>
-            <a:pPr algn="l" indent="0" marL="0">
+            <a:pPr marL="0" indent="0" algn="l">
               <a:lnSpc>
                 <a:spcPts val="1960"/>
               </a:lnSpc>
@@ -3379,7 +3210,7 @@
           </a:bodyPr>
           <a:lstStyle/>
           <a:p>
-            <a:pPr algn="l" indent="0" marL="0">
+            <a:pPr marL="0" indent="0" algn="l">
               <a:lnSpc>
                 <a:spcPts val="1680"/>
               </a:lnSpc>
@@ -3416,6 +3247,7 @@
         <a:solidFill>
           <a:srgbClr val="F7F6F2"/>
         </a:solidFill>
+        <a:effectLst/>
       </p:bgPr>
     </p:bg>
     <p:spTree>
@@ -3455,14 +3287,14 @@
           </a:bodyPr>
           <a:lstStyle/>
           <a:p>
-            <a:pPr algn="l" indent="0" marL="0">
+            <a:pPr marL="0" indent="0" algn="l">
               <a:lnSpc>
                 <a:spcPts val="1820"/>
               </a:lnSpc>
               <a:buNone/>
             </a:pPr>
             <a:r>
-              <a:rPr lang="en-US" sz="1300" b="1" spc="150" kern="0" dirty="0">
+              <a:rPr lang="en-US" sz="1300" b="1" kern="0" spc="150" dirty="0">
                 <a:solidFill>
                   <a:srgbClr val="B4470A"/>
                 </a:solidFill>
@@ -3479,7 +3311,9 @@
       <p:sp>
         <p:nvSpPr>
           <p:cNvPr id="3" name="Text 1"/>
-          <p:cNvSpPr/>
+          <p:cNvSpPr>
+            <a:spLocks noGrp="1"/>
+          </p:cNvSpPr>
           <p:nvPr>
             <p:ph type="title"/>
           </p:nvPr>
@@ -3501,14 +3335,14 @@
           </a:bodyPr>
           <a:lstStyle/>
           <a:p>
-            <a:pPr algn="l" indent="0" marL="0">
+            <a:pPr marL="0" indent="0" algn="l">
               <a:lnSpc>
                 <a:spcPts val="3960"/>
               </a:lnSpc>
               <a:buNone/>
             </a:pPr>
             <a:r>
-              <a:rPr lang="en-US" sz="3600" b="1" i="0" dirty="0">
+              <a:rPr lang="en-US" sz="3600" b="1" i="0" dirty="0" err="1">
                 <a:solidFill>
                   <a:srgbClr val="14213D"/>
                 </a:solidFill>
@@ -3516,7 +3350,40 @@
                 <a:ea typeface="Rubik" pitchFamily="34" charset="-122"/>
                 <a:cs typeface="Rubik" pitchFamily="34" charset="-120"/>
               </a:rPr>
-              <a:t>Recorrer los listados como una persona</a:t>
+              <a:t>Recorre</a:t>
+            </a:r>
+            <a:r>
+              <a:rPr lang="en-US" sz="3600" b="1" i="0" dirty="0">
+                <a:solidFill>
+                  <a:srgbClr val="14213D"/>
+                </a:solidFill>
+                <a:latin typeface="Rubik" pitchFamily="34" charset="0"/>
+                <a:ea typeface="Rubik" pitchFamily="34" charset="-122"/>
+                <a:cs typeface="Rubik" pitchFamily="34" charset="-120"/>
+              </a:rPr>
+              <a:t> </a:t>
+            </a:r>
+            <a:r>
+              <a:rPr lang="en-US" sz="3600" b="1" i="0" dirty="0" err="1">
+                <a:solidFill>
+                  <a:srgbClr val="14213D"/>
+                </a:solidFill>
+                <a:latin typeface="Rubik" pitchFamily="34" charset="0"/>
+                <a:ea typeface="Rubik" pitchFamily="34" charset="-122"/>
+                <a:cs typeface="Rubik" pitchFamily="34" charset="-120"/>
+              </a:rPr>
+              <a:t>los</a:t>
+            </a:r>
+            <a:r>
+              <a:rPr lang="en-US" sz="3600" b="1" i="0" dirty="0">
+                <a:solidFill>
+                  <a:srgbClr val="14213D"/>
+                </a:solidFill>
+                <a:latin typeface="Rubik" pitchFamily="34" charset="0"/>
+                <a:ea typeface="Rubik" pitchFamily="34" charset="-122"/>
+                <a:cs typeface="Rubik" pitchFamily="34" charset="-120"/>
+              </a:rPr>
+              <a:t> listados como una persona</a:t>
             </a:r>
             <a:endParaRPr lang="en-US" sz="3600" dirty="0"/>
           </a:p>
@@ -3545,7 +3412,7 @@
           </a:bodyPr>
           <a:lstStyle/>
           <a:p>
-            <a:pPr algn="l" indent="0" marL="0">
+            <a:pPr marL="0" indent="0" algn="l">
               <a:lnSpc>
                 <a:spcPts val="4800"/>
               </a:lnSpc>
@@ -3589,7 +3456,7 @@
           </a:bodyPr>
           <a:lstStyle/>
           <a:p>
-            <a:pPr algn="l" indent="0" marL="0">
+            <a:pPr marL="0" indent="0" algn="l">
               <a:lnSpc>
                 <a:spcPts val="1960"/>
               </a:lnSpc>
@@ -3633,7 +3500,7 @@
           </a:bodyPr>
           <a:lstStyle/>
           <a:p>
-            <a:pPr algn="l" indent="0" marL="0">
+            <a:pPr marL="0" indent="0" algn="l">
               <a:lnSpc>
                 <a:spcPts val="2800"/>
               </a:lnSpc>
@@ -3677,7 +3544,7 @@
           </a:bodyPr>
           <a:lstStyle/>
           <a:p>
-            <a:pPr algn="l" indent="0" marL="0">
+            <a:pPr marL="0" indent="0" algn="l">
               <a:lnSpc>
                 <a:spcPts val="1960"/>
               </a:lnSpc>
@@ -3721,7 +3588,7 @@
           </a:bodyPr>
           <a:lstStyle/>
           <a:p>
-            <a:pPr algn="l" indent="0" marL="0">
+            <a:pPr marL="0" indent="0" algn="l">
               <a:lnSpc>
                 <a:spcPts val="2100"/>
               </a:lnSpc>
@@ -3765,7 +3632,7 @@
           </a:bodyPr>
           <a:lstStyle/>
           <a:p>
-            <a:pPr algn="l" indent="0" marL="0">
+            <a:pPr marL="0" indent="0" algn="l">
               <a:lnSpc>
                 <a:spcPts val="2025"/>
               </a:lnSpc>
@@ -3820,7 +3687,7 @@
           </a:bodyPr>
           <a:lstStyle/>
           <a:p>
-            <a:pPr algn="l" indent="0" marL="0">
+            <a:pPr marL="0" indent="0" algn="l">
               <a:lnSpc>
                 <a:spcPts val="2100"/>
               </a:lnSpc>
@@ -3864,7 +3731,7 @@
           </a:bodyPr>
           <a:lstStyle/>
           <a:p>
-            <a:pPr algn="l" indent="0" marL="0">
+            <a:pPr marL="0" indent="0" algn="l">
               <a:lnSpc>
                 <a:spcPts val="2025"/>
               </a:lnSpc>
@@ -3919,7 +3786,7 @@
           </a:bodyPr>
           <a:lstStyle/>
           <a:p>
-            <a:pPr algn="l" indent="0" marL="0">
+            <a:pPr marL="0" indent="0" algn="l">
               <a:lnSpc>
                 <a:spcPts val="2100"/>
               </a:lnSpc>
@@ -3963,7 +3830,7 @@
           </a:bodyPr>
           <a:lstStyle/>
           <a:p>
-            <a:pPr algn="l" indent="0" marL="0">
+            <a:pPr marL="0" indent="0" algn="l">
               <a:lnSpc>
                 <a:spcPts val="2025"/>
               </a:lnSpc>
@@ -4018,7 +3885,7 @@
           </a:bodyPr>
           <a:lstStyle/>
           <a:p>
-            <a:pPr algn="l" indent="0" marL="0">
+            <a:pPr marL="0" indent="0" algn="l">
               <a:lnSpc>
                 <a:spcPts val="2100"/>
               </a:lnSpc>
@@ -4062,7 +3929,7 @@
           </a:bodyPr>
           <a:lstStyle/>
           <a:p>
-            <a:pPr algn="l" indent="0" marL="0">
+            <a:pPr marL="0" indent="0" algn="l">
               <a:lnSpc>
                 <a:spcPts val="2025"/>
               </a:lnSpc>
@@ -4077,10 +3944,10 @@
                 <a:ea typeface="IBM Plex Sans" pitchFamily="34" charset="-122"/>
                 <a:cs typeface="IBM Plex Sans" pitchFamily="34" charset="-120"/>
               </a:rPr>
-              <a:t>Ritmo humano</a:t>
-            </a:r>
-            <a:r>
-              <a:rPr lang="en-US" sz="1500" dirty="0">
+              <a:t>Ritmo “</a:t>
+            </a:r>
+            <a:r>
+              <a:rPr lang="en-US" sz="1500" b="1" dirty="0" err="1">
                 <a:solidFill>
                   <a:srgbClr val="14213D"/>
                 </a:solidFill>
@@ -4088,7 +3955,51 @@
                 <a:ea typeface="IBM Plex Sans" pitchFamily="34" charset="-122"/>
                 <a:cs typeface="IBM Plex Sans" pitchFamily="34" charset="-120"/>
               </a:rPr>
-              <a:t>: una página cada ~5 s, pausas al azar, un solo navegador.</a:t>
+              <a:t>humano</a:t>
+            </a:r>
+            <a:r>
+              <a:rPr lang="en-US" sz="1500" b="1" dirty="0">
+                <a:solidFill>
+                  <a:srgbClr val="14213D"/>
+                </a:solidFill>
+                <a:latin typeface="IBM Plex Sans" pitchFamily="34" charset="0"/>
+                <a:ea typeface="IBM Plex Sans" pitchFamily="34" charset="-122"/>
+                <a:cs typeface="IBM Plex Sans" pitchFamily="34" charset="-120"/>
+              </a:rPr>
+              <a:t>”</a:t>
+            </a:r>
+            <a:r>
+              <a:rPr lang="en-US" sz="1500" dirty="0">
+                <a:solidFill>
+                  <a:srgbClr val="14213D"/>
+                </a:solidFill>
+                <a:latin typeface="IBM Plex Sans" pitchFamily="34" charset="0"/>
+                <a:ea typeface="IBM Plex Sans" pitchFamily="34" charset="-122"/>
+                <a:cs typeface="IBM Plex Sans" pitchFamily="34" charset="-120"/>
+              </a:rPr>
+              <a:t>: una página </a:t>
+            </a:r>
+            <a:r>
+              <a:rPr lang="en-US" sz="1500" dirty="0" err="1">
+                <a:solidFill>
+                  <a:srgbClr val="14213D"/>
+                </a:solidFill>
+                <a:latin typeface="IBM Plex Sans" pitchFamily="34" charset="0"/>
+                <a:ea typeface="IBM Plex Sans" pitchFamily="34" charset="-122"/>
+                <a:cs typeface="IBM Plex Sans" pitchFamily="34" charset="-120"/>
+              </a:rPr>
+              <a:t>cada</a:t>
+            </a:r>
+            <a:r>
+              <a:rPr lang="en-US" sz="1500" dirty="0">
+                <a:solidFill>
+                  <a:srgbClr val="14213D"/>
+                </a:solidFill>
+                <a:latin typeface="IBM Plex Sans" pitchFamily="34" charset="0"/>
+                <a:ea typeface="IBM Plex Sans" pitchFamily="34" charset="-122"/>
+                <a:cs typeface="IBM Plex Sans" pitchFamily="34" charset="-120"/>
+              </a:rPr>
+              <a:t> ~10 s, pausas al azar, un solo navegador.</a:t>
             </a:r>
             <a:endParaRPr lang="en-US" sz="1500" dirty="0"/>
           </a:p>
@@ -4117,7 +4028,7 @@
           </a:bodyPr>
           <a:lstStyle/>
           <a:p>
-            <a:pPr algn="l" indent="0" marL="0">
+            <a:pPr marL="0" indent="0" algn="l">
               <a:lnSpc>
                 <a:spcPts val="1680"/>
               </a:lnSpc>
@@ -4154,6 +4065,7 @@
         <a:solidFill>
           <a:srgbClr val="F7F6F2"/>
         </a:solidFill>
+        <a:effectLst/>
       </p:bgPr>
     </p:bg>
     <p:spTree>
@@ -4193,14 +4105,14 @@
           </a:bodyPr>
           <a:lstStyle/>
           <a:p>
-            <a:pPr algn="l" indent="0" marL="0">
+            <a:pPr marL="0" indent="0" algn="l">
               <a:lnSpc>
                 <a:spcPts val="1820"/>
               </a:lnSpc>
               <a:buNone/>
             </a:pPr>
             <a:r>
-              <a:rPr lang="en-US" sz="1300" b="1" spc="150" kern="0" dirty="0">
+              <a:rPr lang="en-US" sz="1300" b="1" kern="0" spc="150" dirty="0">
                 <a:solidFill>
                   <a:srgbClr val="B4470A"/>
                 </a:solidFill>
@@ -4217,7 +4129,9 @@
       <p:sp>
         <p:nvSpPr>
           <p:cNvPr id="3" name="Text 1"/>
-          <p:cNvSpPr/>
+          <p:cNvSpPr>
+            <a:spLocks noGrp="1"/>
+          </p:cNvSpPr>
           <p:nvPr>
             <p:ph type="title"/>
           </p:nvPr>
@@ -4239,7 +4153,7 @@
           </a:bodyPr>
           <a:lstStyle/>
           <a:p>
-            <a:pPr algn="l" indent="0" marL="0">
+            <a:pPr marL="0" indent="0" algn="l">
               <a:lnSpc>
                 <a:spcPts val="3960"/>
               </a:lnSpc>
@@ -4276,15 +4190,27 @@
         </p:nvGraphicFramePr>
         <p:xfrm>
           <a:off x="825500" y="2169021"/>
-          <a:ext cx="10553700" cy="2564606"/>
+          <a:ext cx="10553700" cy="2564607"/>
         </p:xfrm>
         <a:graphic>
           <a:graphicData uri="http://schemas.openxmlformats.org/drawingml/2006/table">
             <a:tbl>
               <a:tblPr/>
               <a:tblGrid>
-                <a:gridCol w="3377184"/>
-                <a:gridCol w="7176516"/>
+                <a:gridCol w="3377184">
+                  <a:extLst>
+                    <a:ext uri="{9D8B030D-6E8A-4147-A177-3AD203B41FA5}">
+                      <a16:colId xmlns:a16="http://schemas.microsoft.com/office/drawing/2014/main" val="20000"/>
+                    </a:ext>
+                  </a:extLst>
+                </a:gridCol>
+                <a:gridCol w="7176516">
+                  <a:extLst>
+                    <a:ext uri="{9D8B030D-6E8A-4147-A177-3AD203B41FA5}">
+                      <a16:colId xmlns:a16="http://schemas.microsoft.com/office/drawing/2014/main" val="20001"/>
+                    </a:ext>
+                  </a:extLst>
+                </a:gridCol>
               </a:tblGrid>
               <a:tr h="385961">
                 <a:tc>
@@ -4292,7 +4218,7 @@
                     <a:bodyPr/>
                     <a:lstStyle/>
                     <a:p>
-                      <a:pPr indent="0" marL="0">
+                      <a:pPr marL="0" indent="0">
                         <a:lnSpc>
                           <a:spcPts val="1960"/>
                         </a:lnSpc>
@@ -4316,7 +4242,7 @@
                       </a:endParaRPr>
                     </a:p>
                   </a:txBody>
-                  <a:tcPr marL="62230" marR="62230" marT="62230" marB="62230" anchor="t">
+                  <a:tcPr marL="62230" marR="62230" marT="62230" marB="62230">
                     <a:lnL w="12700" cap="flat" cmpd="sng" algn="ctr">
                       <a:solidFill>
                         <a:srgbClr val="C5C4C1"/>
@@ -4363,7 +4289,7 @@
                     <a:bodyPr/>
                     <a:lstStyle/>
                     <a:p>
-                      <a:pPr indent="0" marL="0">
+                      <a:pPr marL="0" indent="0">
                         <a:lnSpc>
                           <a:spcPts val="1960"/>
                         </a:lnSpc>
@@ -4387,7 +4313,7 @@
                       </a:endParaRPr>
                     </a:p>
                   </a:txBody>
-                  <a:tcPr marL="62230" marR="62230" marT="62230" marB="62230" anchor="t">
+                  <a:tcPr marL="62230" marR="62230" marT="62230" marB="62230">
                     <a:lnL w="12700" cap="flat" cmpd="sng" algn="ctr">
                       <a:solidFill>
                         <a:srgbClr val="141E34"/>
@@ -4429,6 +4355,11 @@
                     </a:solidFill>
                   </a:tcPr>
                 </a:tc>
+                <a:extLst>
+                  <a:ext uri="{0D108BD9-81ED-4DB2-BD59-A6C34878D82A}">
+                    <a16:rowId xmlns:a16="http://schemas.microsoft.com/office/drawing/2014/main" val="10000"/>
+                  </a:ext>
+                </a:extLst>
               </a:tr>
               <a:tr h="634802">
                 <a:tc>
@@ -4436,7 +4367,7 @@
                     <a:bodyPr/>
                     <a:lstStyle/>
                     <a:p>
-                      <a:pPr indent="0" marL="0">
+                      <a:pPr marL="0" indent="0">
                         <a:lnSpc>
                           <a:spcPts val="1960"/>
                         </a:lnSpc>
@@ -4460,7 +4391,7 @@
                       </a:endParaRPr>
                     </a:p>
                   </a:txBody>
-                  <a:tcPr marL="62230" marR="62230" marT="62230" marB="62230" anchor="t">
+                  <a:tcPr marL="62230" marR="62230" marT="62230" marB="62230">
                     <a:lnL w="12700" cap="flat" cmpd="sng" algn="ctr">
                       <a:solidFill>
                         <a:srgbClr val="C5C4C1"/>
@@ -4504,7 +4435,7 @@
                     <a:bodyPr/>
                     <a:lstStyle/>
                     <a:p>
-                      <a:pPr indent="0" marL="0">
+                      <a:pPr marL="0" indent="0">
                         <a:lnSpc>
                           <a:spcPts val="1960"/>
                         </a:lnSpc>
@@ -4528,7 +4459,7 @@
                       </a:endParaRPr>
                     </a:p>
                   </a:txBody>
-                  <a:tcPr marL="62230" marR="62230" marT="62230" marB="62230" anchor="t">
+                  <a:tcPr marL="62230" marR="62230" marT="62230" marB="62230">
                     <a:lnL w="12700" cap="flat" cmpd="sng" algn="ctr">
                       <a:solidFill>
                         <a:srgbClr val="C5C4C1"/>
@@ -4567,6 +4498,11 @@
                     </a:lnB>
                   </a:tcPr>
                 </a:tc>
+                <a:extLst>
+                  <a:ext uri="{0D108BD9-81ED-4DB2-BD59-A6C34878D82A}">
+                    <a16:rowId xmlns:a16="http://schemas.microsoft.com/office/drawing/2014/main" val="10001"/>
+                  </a:ext>
+                </a:extLst>
               </a:tr>
               <a:tr h="385961">
                 <a:tc>
@@ -4574,7 +4510,7 @@
                     <a:bodyPr/>
                     <a:lstStyle/>
                     <a:p>
-                      <a:pPr indent="0" marL="0">
+                      <a:pPr marL="0" indent="0">
                         <a:lnSpc>
                           <a:spcPts val="1960"/>
                         </a:lnSpc>
@@ -4598,7 +4534,7 @@
                       </a:endParaRPr>
                     </a:p>
                   </a:txBody>
-                  <a:tcPr marL="62230" marR="62230" marT="62230" marB="62230" anchor="t">
+                  <a:tcPr marL="62230" marR="62230" marT="62230" marB="62230">
                     <a:lnL w="12700" cap="flat" cmpd="sng" algn="ctr">
                       <a:solidFill>
                         <a:srgbClr val="C5C4C1"/>
@@ -4645,7 +4581,7 @@
                     <a:bodyPr/>
                     <a:lstStyle/>
                     <a:p>
-                      <a:pPr indent="0" marL="0">
+                      <a:pPr marL="0" indent="0">
                         <a:lnSpc>
                           <a:spcPts val="1960"/>
                         </a:lnSpc>
@@ -4669,7 +4605,7 @@
                       </a:endParaRPr>
                     </a:p>
                   </a:txBody>
-                  <a:tcPr marL="62230" marR="62230" marT="62230" marB="62230" anchor="t">
+                  <a:tcPr marL="62230" marR="62230" marT="62230" marB="62230">
                     <a:lnL w="12700" cap="flat" cmpd="sng" algn="ctr">
                       <a:solidFill>
                         <a:srgbClr val="BFBDB8"/>
@@ -4711,6 +4647,11 @@
                     </a:solidFill>
                   </a:tcPr>
                 </a:tc>
+                <a:extLst>
+                  <a:ext uri="{0D108BD9-81ED-4DB2-BD59-A6C34878D82A}">
+                    <a16:rowId xmlns:a16="http://schemas.microsoft.com/office/drawing/2014/main" val="10002"/>
+                  </a:ext>
+                </a:extLst>
               </a:tr>
               <a:tr h="385961">
                 <a:tc>
@@ -4718,7 +4659,7 @@
                     <a:bodyPr/>
                     <a:lstStyle/>
                     <a:p>
-                      <a:pPr indent="0" marL="0">
+                      <a:pPr marL="0" indent="0">
                         <a:lnSpc>
                           <a:spcPts val="1960"/>
                         </a:lnSpc>
@@ -4742,7 +4683,7 @@
                       </a:endParaRPr>
                     </a:p>
                   </a:txBody>
-                  <a:tcPr marL="62230" marR="62230" marT="62230" marB="62230" anchor="t">
+                  <a:tcPr marL="62230" marR="62230" marT="62230" marB="62230">
                     <a:lnL w="12700" cap="flat" cmpd="sng" algn="ctr">
                       <a:solidFill>
                         <a:srgbClr val="C5C4C1"/>
@@ -4786,7 +4727,7 @@
                     <a:bodyPr/>
                     <a:lstStyle/>
                     <a:p>
-                      <a:pPr indent="0" marL="0">
+                      <a:pPr marL="0" indent="0">
                         <a:lnSpc>
                           <a:spcPts val="1960"/>
                         </a:lnSpc>
@@ -4810,7 +4751,7 @@
                       </a:endParaRPr>
                     </a:p>
                   </a:txBody>
-                  <a:tcPr marL="62230" marR="62230" marT="62230" marB="62230" anchor="t">
+                  <a:tcPr marL="62230" marR="62230" marT="62230" marB="62230">
                     <a:lnL w="12700" cap="flat" cmpd="sng" algn="ctr">
                       <a:solidFill>
                         <a:srgbClr val="C5C4C1"/>
@@ -4849,6 +4790,11 @@
                     </a:lnB>
                   </a:tcPr>
                 </a:tc>
+                <a:extLst>
+                  <a:ext uri="{0D108BD9-81ED-4DB2-BD59-A6C34878D82A}">
+                    <a16:rowId xmlns:a16="http://schemas.microsoft.com/office/drawing/2014/main" val="10003"/>
+                  </a:ext>
+                </a:extLst>
               </a:tr>
               <a:tr h="385961">
                 <a:tc>
@@ -4856,7 +4802,7 @@
                     <a:bodyPr/>
                     <a:lstStyle/>
                     <a:p>
-                      <a:pPr indent="0" marL="0">
+                      <a:pPr marL="0" indent="0">
                         <a:lnSpc>
                           <a:spcPts val="1960"/>
                         </a:lnSpc>
@@ -4880,7 +4826,7 @@
                       </a:endParaRPr>
                     </a:p>
                   </a:txBody>
-                  <a:tcPr marL="62230" marR="62230" marT="62230" marB="62230" anchor="t">
+                  <a:tcPr marL="62230" marR="62230" marT="62230" marB="62230">
                     <a:lnL w="12700" cap="flat" cmpd="sng" algn="ctr">
                       <a:solidFill>
                         <a:srgbClr val="C5C4C1"/>
@@ -4927,7 +4873,7 @@
                     <a:bodyPr/>
                     <a:lstStyle/>
                     <a:p>
-                      <a:pPr indent="0" marL="0">
+                      <a:pPr marL="0" indent="0">
                         <a:lnSpc>
                           <a:spcPts val="1960"/>
                         </a:lnSpc>
@@ -4951,7 +4897,7 @@
                       </a:endParaRPr>
                     </a:p>
                   </a:txBody>
-                  <a:tcPr marL="62230" marR="62230" marT="62230" marB="62230" anchor="t">
+                  <a:tcPr marL="62230" marR="62230" marT="62230" marB="62230">
                     <a:lnL w="12700" cap="flat" cmpd="sng" algn="ctr">
                       <a:solidFill>
                         <a:srgbClr val="BFBDB8"/>
@@ -4993,6 +4939,11 @@
                     </a:solidFill>
                   </a:tcPr>
                 </a:tc>
+                <a:extLst>
+                  <a:ext uri="{0D108BD9-81ED-4DB2-BD59-A6C34878D82A}">
+                    <a16:rowId xmlns:a16="http://schemas.microsoft.com/office/drawing/2014/main" val="10004"/>
+                  </a:ext>
+                </a:extLst>
               </a:tr>
               <a:tr h="385961">
                 <a:tc>
@@ -5000,7 +4951,7 @@
                     <a:bodyPr/>
                     <a:lstStyle/>
                     <a:p>
-                      <a:pPr indent="0" marL="0">
+                      <a:pPr marL="0" indent="0">
                         <a:lnSpc>
                           <a:spcPts val="1960"/>
                         </a:lnSpc>
@@ -5024,7 +4975,7 @@
                       </a:endParaRPr>
                     </a:p>
                   </a:txBody>
-                  <a:tcPr marL="62230" marR="62230" marT="62230" marB="62230" anchor="t">
+                  <a:tcPr marL="62230" marR="62230" marT="62230" marB="62230">
                     <a:lnL w="12700" cap="flat" cmpd="sng" algn="ctr">
                       <a:solidFill>
                         <a:srgbClr val="C5C4C1"/>
@@ -5068,7 +5019,7 @@
                     <a:bodyPr/>
                     <a:lstStyle/>
                     <a:p>
-                      <a:pPr indent="0" marL="0">
+                      <a:pPr marL="0" indent="0">
                         <a:lnSpc>
                           <a:spcPts val="1960"/>
                         </a:lnSpc>
@@ -5092,7 +5043,7 @@
                       </a:endParaRPr>
                     </a:p>
                   </a:txBody>
-                  <a:tcPr marL="62230" marR="62230" marT="62230" marB="62230" anchor="t">
+                  <a:tcPr marL="62230" marR="62230" marT="62230" marB="62230">
                     <a:lnL w="12700" cap="flat" cmpd="sng" algn="ctr">
                       <a:solidFill>
                         <a:srgbClr val="C5C4C1"/>
@@ -5131,6 +5082,11 @@
                     </a:lnB>
                   </a:tcPr>
                 </a:tc>
+                <a:extLst>
+                  <a:ext uri="{0D108BD9-81ED-4DB2-BD59-A6C34878D82A}">
+                    <a16:rowId xmlns:a16="http://schemas.microsoft.com/office/drawing/2014/main" val="10005"/>
+                  </a:ext>
+                </a:extLst>
               </a:tr>
             </a:tbl>
           </a:graphicData>
@@ -5159,7 +5115,7 @@
           </a:bodyPr>
           <a:lstStyle/>
           <a:p>
-            <a:pPr algn="l" indent="0" marL="0">
+            <a:pPr marL="0" indent="0" algn="l">
               <a:lnSpc>
                 <a:spcPts val="1680"/>
               </a:lnSpc>
@@ -5196,6 +5152,7 @@
         <a:solidFill>
           <a:srgbClr val="14213D"/>
         </a:solidFill>
+        <a:effectLst/>
       </p:bgPr>
     </p:bg>
     <p:spTree>
@@ -5235,14 +5192,14 @@
           </a:bodyPr>
           <a:lstStyle/>
           <a:p>
-            <a:pPr algn="l" indent="0" marL="0">
+            <a:pPr marL="0" indent="0" algn="l">
               <a:lnSpc>
                 <a:spcPts val="1820"/>
               </a:lnSpc>
               <a:buNone/>
             </a:pPr>
             <a:r>
-              <a:rPr lang="en-US" sz="1300" b="1" spc="150" kern="0" dirty="0">
+              <a:rPr lang="en-US" sz="1300" b="1" kern="0" spc="150" dirty="0">
                 <a:solidFill>
                   <a:srgbClr val="F4A261"/>
                 </a:solidFill>
@@ -5259,7 +5216,9 @@
       <p:sp>
         <p:nvSpPr>
           <p:cNvPr id="3" name="Text 1"/>
-          <p:cNvSpPr/>
+          <p:cNvSpPr>
+            <a:spLocks noGrp="1"/>
+          </p:cNvSpPr>
           <p:nvPr>
             <p:ph type="title"/>
           </p:nvPr>
@@ -5281,7 +5240,7 @@
           </a:bodyPr>
           <a:lstStyle/>
           <a:p>
-            <a:pPr algn="l" indent="0" marL="0">
+            <a:pPr marL="0" indent="0" algn="l">
               <a:lnSpc>
                 <a:spcPts val="3960"/>
               </a:lnSpc>
@@ -5323,6 +5282,13 @@
           </a:solidFill>
           <a:ln/>
         </p:spPr>
+        <p:txBody>
+          <a:bodyPr/>
+          <a:lstStyle/>
+          <a:p>
+            <a:endParaRPr lang="en-US"/>
+          </a:p>
+        </p:txBody>
       </p:sp>
       <p:sp>
         <p:nvSpPr>
@@ -5347,7 +5313,7 @@
           </a:bodyPr>
           <a:lstStyle/>
           <a:p>
-            <a:pPr algn="l" indent="0" marL="0">
+            <a:pPr marL="0" indent="0" algn="l">
               <a:lnSpc>
                 <a:spcPts val="3600"/>
               </a:lnSpc>
@@ -5391,7 +5357,7 @@
           </a:bodyPr>
           <a:lstStyle/>
           <a:p>
-            <a:pPr algn="l" indent="0" marL="0">
+            <a:pPr marL="0" indent="0" algn="l">
               <a:lnSpc>
                 <a:spcPts val="1890"/>
               </a:lnSpc>
@@ -5433,6 +5399,13 @@
           </a:solidFill>
           <a:ln/>
         </p:spPr>
+        <p:txBody>
+          <a:bodyPr/>
+          <a:lstStyle/>
+          <a:p>
+            <a:endParaRPr lang="en-US"/>
+          </a:p>
+        </p:txBody>
       </p:sp>
       <p:sp>
         <p:nvSpPr>
@@ -5457,7 +5430,7 @@
           </a:bodyPr>
           <a:lstStyle/>
           <a:p>
-            <a:pPr algn="l" indent="0" marL="0">
+            <a:pPr marL="0" indent="0" algn="l">
               <a:lnSpc>
                 <a:spcPts val="3600"/>
               </a:lnSpc>
@@ -5501,7 +5474,7 @@
           </a:bodyPr>
           <a:lstStyle/>
           <a:p>
-            <a:pPr algn="l" indent="0" marL="0">
+            <a:pPr marL="0" indent="0" algn="l">
               <a:lnSpc>
                 <a:spcPts val="1890"/>
               </a:lnSpc>
@@ -5543,6 +5516,13 @@
           </a:solidFill>
           <a:ln/>
         </p:spPr>
+        <p:txBody>
+          <a:bodyPr/>
+          <a:lstStyle/>
+          <a:p>
+            <a:endParaRPr lang="en-US"/>
+          </a:p>
+        </p:txBody>
       </p:sp>
       <p:sp>
         <p:nvSpPr>
@@ -5567,7 +5547,7 @@
           </a:bodyPr>
           <a:lstStyle/>
           <a:p>
-            <a:pPr algn="l" indent="0" marL="0">
+            <a:pPr marL="0" indent="0" algn="l">
               <a:lnSpc>
                 <a:spcPts val="3600"/>
               </a:lnSpc>
@@ -5611,7 +5591,7 @@
           </a:bodyPr>
           <a:lstStyle/>
           <a:p>
-            <a:pPr algn="l" indent="0" marL="0">
+            <a:pPr marL="0" indent="0" algn="l">
               <a:lnSpc>
                 <a:spcPts val="1890"/>
               </a:lnSpc>
@@ -5653,6 +5633,13 @@
           </a:solidFill>
           <a:ln/>
         </p:spPr>
+        <p:txBody>
+          <a:bodyPr/>
+          <a:lstStyle/>
+          <a:p>
+            <a:endParaRPr lang="en-US"/>
+          </a:p>
+        </p:txBody>
       </p:sp>
       <p:sp>
         <p:nvSpPr>
@@ -5677,7 +5664,7 @@
           </a:bodyPr>
           <a:lstStyle/>
           <a:p>
-            <a:pPr algn="l" indent="0" marL="0">
+            <a:pPr marL="0" indent="0" algn="l">
               <a:lnSpc>
                 <a:spcPts val="3600"/>
               </a:lnSpc>
@@ -5721,7 +5708,7 @@
           </a:bodyPr>
           <a:lstStyle/>
           <a:p>
-            <a:pPr algn="l" indent="0" marL="0">
+            <a:pPr marL="0" indent="0" algn="l">
               <a:lnSpc>
                 <a:spcPts val="1890"/>
               </a:lnSpc>
@@ -5763,6 +5750,13 @@
           </a:solidFill>
           <a:ln/>
         </p:spPr>
+        <p:txBody>
+          <a:bodyPr/>
+          <a:lstStyle/>
+          <a:p>
+            <a:endParaRPr lang="en-US"/>
+          </a:p>
+        </p:txBody>
       </p:sp>
       <p:sp>
         <p:nvSpPr>
@@ -5787,7 +5781,7 @@
           </a:bodyPr>
           <a:lstStyle/>
           <a:p>
-            <a:pPr algn="l" indent="0" marL="0">
+            <a:pPr marL="0" indent="0" algn="l">
               <a:lnSpc>
                 <a:spcPts val="3600"/>
               </a:lnSpc>
@@ -5831,7 +5825,7 @@
           </a:bodyPr>
           <a:lstStyle/>
           <a:p>
-            <a:pPr algn="l" indent="0" marL="0">
+            <a:pPr marL="0" indent="0" algn="l">
               <a:lnSpc>
                 <a:spcPts val="1890"/>
               </a:lnSpc>
@@ -5873,6 +5867,13 @@
           </a:solidFill>
           <a:ln/>
         </p:spPr>
+        <p:txBody>
+          <a:bodyPr/>
+          <a:lstStyle/>
+          <a:p>
+            <a:endParaRPr lang="en-US"/>
+          </a:p>
+        </p:txBody>
       </p:sp>
       <p:sp>
         <p:nvSpPr>
@@ -5897,7 +5898,7 @@
           </a:bodyPr>
           <a:lstStyle/>
           <a:p>
-            <a:pPr algn="l" indent="0" marL="0">
+            <a:pPr marL="0" indent="0" algn="l">
               <a:lnSpc>
                 <a:spcPts val="3600"/>
               </a:lnSpc>
@@ -5941,7 +5942,7 @@
           </a:bodyPr>
           <a:lstStyle/>
           <a:p>
-            <a:pPr algn="l" indent="0" marL="0">
+            <a:pPr marL="0" indent="0" algn="l">
               <a:lnSpc>
                 <a:spcPts val="1890"/>
               </a:lnSpc>
@@ -5985,7 +5986,7 @@
           </a:bodyPr>
           <a:lstStyle/>
           <a:p>
-            <a:pPr algn="l" indent="0" marL="0">
+            <a:pPr marL="0" indent="0" algn="l">
               <a:lnSpc>
                 <a:spcPts val="1680"/>
               </a:lnSpc>
@@ -6022,6 +6023,7 @@
         <a:solidFill>
           <a:srgbClr val="F7F6F2"/>
         </a:solidFill>
+        <a:effectLst/>
       </p:bgPr>
     </p:bg>
     <p:spTree>
@@ -6061,14 +6063,14 @@
           </a:bodyPr>
           <a:lstStyle/>
           <a:p>
-            <a:pPr algn="l" indent="0" marL="0">
+            <a:pPr marL="0" indent="0" algn="l">
               <a:lnSpc>
                 <a:spcPts val="1820"/>
               </a:lnSpc>
               <a:buNone/>
             </a:pPr>
             <a:r>
-              <a:rPr lang="en-US" sz="1300" b="1" spc="150" kern="0" dirty="0">
+              <a:rPr lang="en-US" sz="1300" b="1" kern="0" spc="150" dirty="0">
                 <a:solidFill>
                   <a:srgbClr val="B4470A"/>
                 </a:solidFill>
@@ -6085,7 +6087,9 @@
       <p:sp>
         <p:nvSpPr>
           <p:cNvPr id="3" name="Text 1"/>
-          <p:cNvSpPr/>
+          <p:cNvSpPr>
+            <a:spLocks noGrp="1"/>
+          </p:cNvSpPr>
           <p:nvPr>
             <p:ph type="title"/>
           </p:nvPr>
@@ -6107,7 +6111,7 @@
           </a:bodyPr>
           <a:lstStyle/>
           <a:p>
-            <a:pPr algn="l" indent="0" marL="0">
+            <a:pPr marL="0" indent="0" algn="l">
               <a:lnSpc>
                 <a:spcPts val="3960"/>
               </a:lnSpc>
@@ -6154,6 +6158,13 @@
             <a:prstDash val="solid"/>
           </a:ln>
         </p:spPr>
+        <p:txBody>
+          <a:bodyPr/>
+          <a:lstStyle/>
+          <a:p>
+            <a:endParaRPr lang="en-US"/>
+          </a:p>
+        </p:txBody>
       </p:sp>
       <p:sp>
         <p:nvSpPr>
@@ -6178,7 +6189,7 @@
           </a:bodyPr>
           <a:lstStyle/>
           <a:p>
-            <a:pPr algn="l" indent="0" marL="0">
+            <a:pPr marL="0" indent="0" algn="l">
               <a:lnSpc>
                 <a:spcPts val="2040"/>
               </a:lnSpc>
@@ -6222,7 +6233,7 @@
           </a:bodyPr>
           <a:lstStyle/>
           <a:p>
-            <a:pPr algn="l" indent="0" marL="0">
+            <a:pPr marL="0" indent="0" algn="l">
               <a:lnSpc>
                 <a:spcPts val="1960"/>
               </a:lnSpc>
@@ -6269,6 +6280,13 @@
             <a:prstDash val="solid"/>
           </a:ln>
         </p:spPr>
+        <p:txBody>
+          <a:bodyPr/>
+          <a:lstStyle/>
+          <a:p>
+            <a:endParaRPr lang="en-US"/>
+          </a:p>
+        </p:txBody>
       </p:sp>
       <p:sp>
         <p:nvSpPr>
@@ -6293,7 +6311,7 @@
           </a:bodyPr>
           <a:lstStyle/>
           <a:p>
-            <a:pPr algn="l" indent="0" marL="0">
+            <a:pPr marL="0" indent="0" algn="l">
               <a:lnSpc>
                 <a:spcPts val="2040"/>
               </a:lnSpc>
@@ -6337,7 +6355,7 @@
           </a:bodyPr>
           <a:lstStyle/>
           <a:p>
-            <a:pPr algn="l" indent="0" marL="0">
+            <a:pPr marL="0" indent="0" algn="l">
               <a:lnSpc>
                 <a:spcPts val="1960"/>
               </a:lnSpc>
@@ -6384,6 +6402,13 @@
             <a:prstDash val="solid"/>
           </a:ln>
         </p:spPr>
+        <p:txBody>
+          <a:bodyPr/>
+          <a:lstStyle/>
+          <a:p>
+            <a:endParaRPr lang="en-US"/>
+          </a:p>
+        </p:txBody>
       </p:sp>
       <p:sp>
         <p:nvSpPr>
@@ -6408,7 +6433,7 @@
           </a:bodyPr>
           <a:lstStyle/>
           <a:p>
-            <a:pPr algn="l" indent="0" marL="0">
+            <a:pPr marL="0" indent="0" algn="l">
               <a:lnSpc>
                 <a:spcPts val="2040"/>
               </a:lnSpc>
@@ -6452,7 +6477,7 @@
           </a:bodyPr>
           <a:lstStyle/>
           <a:p>
-            <a:pPr algn="l" indent="0" marL="0">
+            <a:pPr marL="0" indent="0" algn="l">
               <a:lnSpc>
                 <a:spcPts val="1960"/>
               </a:lnSpc>
@@ -6499,6 +6524,13 @@
             <a:prstDash val="solid"/>
           </a:ln>
         </p:spPr>
+        <p:txBody>
+          <a:bodyPr/>
+          <a:lstStyle/>
+          <a:p>
+            <a:endParaRPr lang="en-US"/>
+          </a:p>
+        </p:txBody>
       </p:sp>
       <p:sp>
         <p:nvSpPr>
@@ -6523,7 +6555,7 @@
           </a:bodyPr>
           <a:lstStyle/>
           <a:p>
-            <a:pPr algn="l" indent="0" marL="0">
+            <a:pPr marL="0" indent="0" algn="l">
               <a:lnSpc>
                 <a:spcPts val="2040"/>
               </a:lnSpc>
@@ -6567,7 +6599,7 @@
           </a:bodyPr>
           <a:lstStyle/>
           <a:p>
-            <a:pPr algn="l" indent="0" marL="0">
+            <a:pPr marL="0" indent="0" algn="l">
               <a:lnSpc>
                 <a:spcPts val="1960"/>
               </a:lnSpc>
@@ -6611,7 +6643,7 @@
           </a:bodyPr>
           <a:lstStyle/>
           <a:p>
-            <a:pPr algn="l" indent="0" marL="0">
+            <a:pPr marL="0" indent="0" algn="l">
               <a:lnSpc>
                 <a:spcPts val="1680"/>
               </a:lnSpc>
@@ -6648,6 +6680,7 @@
         <a:solidFill>
           <a:srgbClr val="F7F6F2"/>
         </a:solidFill>
+        <a:effectLst/>
       </p:bgPr>
     </p:bg>
     <p:spTree>
@@ -6687,14 +6720,14 @@
           </a:bodyPr>
           <a:lstStyle/>
           <a:p>
-            <a:pPr algn="l" indent="0" marL="0">
+            <a:pPr marL="0" indent="0" algn="l">
               <a:lnSpc>
                 <a:spcPts val="1820"/>
               </a:lnSpc>
               <a:buNone/>
             </a:pPr>
             <a:r>
-              <a:rPr lang="en-US" sz="1300" b="1" spc="150" kern="0" dirty="0">
+              <a:rPr lang="en-US" sz="1300" b="1" kern="0" spc="150" dirty="0">
                 <a:solidFill>
                   <a:srgbClr val="B4470A"/>
                 </a:solidFill>
@@ -6711,7 +6744,9 @@
       <p:sp>
         <p:nvSpPr>
           <p:cNvPr id="3" name="Text 1"/>
-          <p:cNvSpPr/>
+          <p:cNvSpPr>
+            <a:spLocks noGrp="1"/>
+          </p:cNvSpPr>
           <p:nvPr>
             <p:ph type="title"/>
           </p:nvPr>
@@ -6733,7 +6768,7 @@
           </a:bodyPr>
           <a:lstStyle/>
           <a:p>
-            <a:pPr algn="l" indent="0" marL="0">
+            <a:pPr marL="0" indent="0" algn="l">
               <a:lnSpc>
                 <a:spcPts val="3960"/>
               </a:lnSpc>
@@ -6770,16 +6805,34 @@
         </p:nvGraphicFramePr>
         <p:xfrm>
           <a:off x="825500" y="2671862"/>
-          <a:ext cx="6591300" cy="2178645"/>
+          <a:ext cx="6591300" cy="2178646"/>
         </p:xfrm>
         <a:graphic>
           <a:graphicData uri="http://schemas.openxmlformats.org/drawingml/2006/table">
             <a:tbl>
               <a:tblPr/>
               <a:tblGrid>
-                <a:gridCol w="3427476"/>
-                <a:gridCol w="1581912"/>
-                <a:gridCol w="1581912"/>
+                <a:gridCol w="3427476">
+                  <a:extLst>
+                    <a:ext uri="{9D8B030D-6E8A-4147-A177-3AD203B41FA5}">
+                      <a16:colId xmlns:a16="http://schemas.microsoft.com/office/drawing/2014/main" val="20000"/>
+                    </a:ext>
+                  </a:extLst>
+                </a:gridCol>
+                <a:gridCol w="1581912">
+                  <a:extLst>
+                    <a:ext uri="{9D8B030D-6E8A-4147-A177-3AD203B41FA5}">
+                      <a16:colId xmlns:a16="http://schemas.microsoft.com/office/drawing/2014/main" val="20001"/>
+                    </a:ext>
+                  </a:extLst>
+                </a:gridCol>
+                <a:gridCol w="1581912">
+                  <a:extLst>
+                    <a:ext uri="{9D8B030D-6E8A-4147-A177-3AD203B41FA5}">
+                      <a16:colId xmlns:a16="http://schemas.microsoft.com/office/drawing/2014/main" val="20002"/>
+                    </a:ext>
+                  </a:extLst>
+                </a:gridCol>
               </a:tblGrid>
               <a:tr h="634802">
                 <a:tc>
@@ -6787,7 +6840,7 @@
                     <a:bodyPr/>
                     <a:lstStyle/>
                     <a:p>
-                      <a:pPr indent="0" marL="0">
+                      <a:pPr marL="0" indent="0">
                         <a:lnSpc>
                           <a:spcPts val="1960"/>
                         </a:lnSpc>
@@ -6811,7 +6864,7 @@
                       </a:endParaRPr>
                     </a:p>
                   </a:txBody>
-                  <a:tcPr marL="62230" marR="62230" marT="62230" marB="62230" anchor="t">
+                  <a:tcPr marL="62230" marR="62230" marT="62230" marB="62230">
                     <a:lnL w="12700" cap="flat" cmpd="sng" algn="ctr">
                       <a:solidFill>
                         <a:srgbClr val="C5C4C1"/>
@@ -6858,7 +6911,7 @@
                     <a:bodyPr/>
                     <a:lstStyle/>
                     <a:p>
-                      <a:pPr algn="r" indent="0" marL="0">
+                      <a:pPr marL="0" indent="0" algn="r">
                         <a:lnSpc>
                           <a:spcPts val="1960"/>
                         </a:lnSpc>
@@ -6882,7 +6935,7 @@
                       </a:endParaRPr>
                     </a:p>
                   </a:txBody>
-                  <a:tcPr marL="62230" marR="62230" marT="62230" marB="62230" anchor="t">
+                  <a:tcPr marL="62230" marR="62230" marT="62230" marB="62230">
                     <a:lnL w="12700" cap="flat" cmpd="sng" algn="ctr">
                       <a:solidFill>
                         <a:srgbClr val="141E34"/>
@@ -6929,7 +6982,7 @@
                     <a:bodyPr/>
                     <a:lstStyle/>
                     <a:p>
-                      <a:pPr algn="r" indent="0" marL="0">
+                      <a:pPr marL="0" indent="0" algn="r">
                         <a:lnSpc>
                           <a:spcPts val="1960"/>
                         </a:lnSpc>
@@ -6953,7 +7006,7 @@
                       </a:endParaRPr>
                     </a:p>
                   </a:txBody>
-                  <a:tcPr marL="62230" marR="62230" marT="62230" marB="62230" anchor="t">
+                  <a:tcPr marL="62230" marR="62230" marT="62230" marB="62230">
                     <a:lnL w="12700" cap="flat" cmpd="sng" algn="ctr">
                       <a:solidFill>
                         <a:srgbClr val="141E34"/>
@@ -6995,6 +7048,11 @@
                     </a:solidFill>
                   </a:tcPr>
                 </a:tc>
+                <a:extLst>
+                  <a:ext uri="{0D108BD9-81ED-4DB2-BD59-A6C34878D82A}">
+                    <a16:rowId xmlns:a16="http://schemas.microsoft.com/office/drawing/2014/main" val="10000"/>
+                  </a:ext>
+                </a:extLst>
               </a:tr>
               <a:tr h="385961">
                 <a:tc>
@@ -7002,7 +7060,7 @@
                     <a:bodyPr/>
                     <a:lstStyle/>
                     <a:p>
-                      <a:pPr indent="0" marL="0">
+                      <a:pPr marL="0" indent="0">
                         <a:lnSpc>
                           <a:spcPts val="1960"/>
                         </a:lnSpc>
@@ -7026,7 +7084,7 @@
                       </a:endParaRPr>
                     </a:p>
                   </a:txBody>
-                  <a:tcPr marL="62230" marR="62230" marT="62230" marB="62230" anchor="t">
+                  <a:tcPr marL="62230" marR="62230" marT="62230" marB="62230">
                     <a:lnL w="12700" cap="flat" cmpd="sng" algn="ctr">
                       <a:solidFill>
                         <a:srgbClr val="C5C4C1"/>
@@ -7070,7 +7128,7 @@
                     <a:bodyPr/>
                     <a:lstStyle/>
                     <a:p>
-                      <a:pPr algn="r" indent="0" marL="0">
+                      <a:pPr marL="0" indent="0" algn="r">
                         <a:lnSpc>
                           <a:spcPts val="1960"/>
                         </a:lnSpc>
@@ -7094,7 +7152,7 @@
                       </a:endParaRPr>
                     </a:p>
                   </a:txBody>
-                  <a:tcPr marL="62230" marR="62230" marT="62230" marB="62230" anchor="t">
+                  <a:tcPr marL="62230" marR="62230" marT="62230" marB="62230">
                     <a:lnL w="12700" cap="flat" cmpd="sng" algn="ctr">
                       <a:solidFill>
                         <a:srgbClr val="C5C4C1"/>
@@ -7138,7 +7196,7 @@
                     <a:bodyPr/>
                     <a:lstStyle/>
                     <a:p>
-                      <a:pPr algn="r" indent="0" marL="0">
+                      <a:pPr marL="0" indent="0" algn="r">
                         <a:lnSpc>
                           <a:spcPts val="1960"/>
                         </a:lnSpc>
@@ -7162,7 +7220,7 @@
                       </a:endParaRPr>
                     </a:p>
                   </a:txBody>
-                  <a:tcPr marL="62230" marR="62230" marT="62230" marB="62230" anchor="t">
+                  <a:tcPr marL="62230" marR="62230" marT="62230" marB="62230">
                     <a:lnL w="12700" cap="flat" cmpd="sng" algn="ctr">
                       <a:solidFill>
                         <a:srgbClr val="C5C4C1"/>
@@ -7201,6 +7259,11 @@
                     </a:lnB>
                   </a:tcPr>
                 </a:tc>
+                <a:extLst>
+                  <a:ext uri="{0D108BD9-81ED-4DB2-BD59-A6C34878D82A}">
+                    <a16:rowId xmlns:a16="http://schemas.microsoft.com/office/drawing/2014/main" val="10001"/>
+                  </a:ext>
+                </a:extLst>
               </a:tr>
               <a:tr h="385961">
                 <a:tc>
@@ -7208,7 +7271,7 @@
                     <a:bodyPr/>
                     <a:lstStyle/>
                     <a:p>
-                      <a:pPr indent="0" marL="0">
+                      <a:pPr marL="0" indent="0">
                         <a:lnSpc>
                           <a:spcPts val="1960"/>
                         </a:lnSpc>
@@ -7232,7 +7295,7 @@
                       </a:endParaRPr>
                     </a:p>
                   </a:txBody>
-                  <a:tcPr marL="62230" marR="62230" marT="62230" marB="62230" anchor="t">
+                  <a:tcPr marL="62230" marR="62230" marT="62230" marB="62230">
                     <a:lnL w="12700" cap="flat" cmpd="sng" algn="ctr">
                       <a:solidFill>
                         <a:srgbClr val="C5C4C1"/>
@@ -7279,7 +7342,7 @@
                     <a:bodyPr/>
                     <a:lstStyle/>
                     <a:p>
-                      <a:pPr algn="r" indent="0" marL="0">
+                      <a:pPr marL="0" indent="0" algn="r">
                         <a:lnSpc>
                           <a:spcPts val="1960"/>
                         </a:lnSpc>
@@ -7303,7 +7366,7 @@
                       </a:endParaRPr>
                     </a:p>
                   </a:txBody>
-                  <a:tcPr marL="62230" marR="62230" marT="62230" marB="62230" anchor="t">
+                  <a:tcPr marL="62230" marR="62230" marT="62230" marB="62230">
                     <a:lnL w="12700" cap="flat" cmpd="sng" algn="ctr">
                       <a:solidFill>
                         <a:srgbClr val="BFBDB8"/>
@@ -7350,7 +7413,7 @@
                     <a:bodyPr/>
                     <a:lstStyle/>
                     <a:p>
-                      <a:pPr algn="r" indent="0" marL="0">
+                      <a:pPr marL="0" indent="0" algn="r">
                         <a:lnSpc>
                           <a:spcPts val="1960"/>
                         </a:lnSpc>
@@ -7374,7 +7437,7 @@
                       </a:endParaRPr>
                     </a:p>
                   </a:txBody>
-                  <a:tcPr marL="62230" marR="62230" marT="62230" marB="62230" anchor="t">
+                  <a:tcPr marL="62230" marR="62230" marT="62230" marB="62230">
                     <a:lnL w="12700" cap="flat" cmpd="sng" algn="ctr">
                       <a:solidFill>
                         <a:srgbClr val="BFBDB8"/>
@@ -7416,6 +7479,11 @@
                     </a:solidFill>
                   </a:tcPr>
                 </a:tc>
+                <a:extLst>
+                  <a:ext uri="{0D108BD9-81ED-4DB2-BD59-A6C34878D82A}">
+                    <a16:rowId xmlns:a16="http://schemas.microsoft.com/office/drawing/2014/main" val="10002"/>
+                  </a:ext>
+                </a:extLst>
               </a:tr>
               <a:tr h="385961">
                 <a:tc>
@@ -7423,7 +7491,7 @@
                     <a:bodyPr/>
                     <a:lstStyle/>
                     <a:p>
-                      <a:pPr indent="0" marL="0">
+                      <a:pPr marL="0" indent="0">
                         <a:lnSpc>
                           <a:spcPts val="1960"/>
                         </a:lnSpc>
@@ -7447,7 +7515,7 @@
                       </a:endParaRPr>
                     </a:p>
                   </a:txBody>
-                  <a:tcPr marL="62230" marR="62230" marT="62230" marB="62230" anchor="t">
+                  <a:tcPr marL="62230" marR="62230" marT="62230" marB="62230">
                     <a:lnL w="12700" cap="flat" cmpd="sng" algn="ctr">
                       <a:solidFill>
                         <a:srgbClr val="C5C4C1"/>
@@ -7491,7 +7559,7 @@
                     <a:bodyPr/>
                     <a:lstStyle/>
                     <a:p>
-                      <a:pPr algn="r" indent="0" marL="0">
+                      <a:pPr marL="0" indent="0" algn="r">
                         <a:lnSpc>
                           <a:spcPts val="1960"/>
                         </a:lnSpc>
@@ -7515,7 +7583,7 @@
                       </a:endParaRPr>
                     </a:p>
                   </a:txBody>
-                  <a:tcPr marL="62230" marR="62230" marT="62230" marB="62230" anchor="t">
+                  <a:tcPr marL="62230" marR="62230" marT="62230" marB="62230">
                     <a:lnL w="12700" cap="flat" cmpd="sng" algn="ctr">
                       <a:solidFill>
                         <a:srgbClr val="C5C4C1"/>
@@ -7559,7 +7627,7 @@
                     <a:bodyPr/>
                     <a:lstStyle/>
                     <a:p>
-                      <a:pPr algn="r" indent="0" marL="0">
+                      <a:pPr marL="0" indent="0" algn="r">
                         <a:lnSpc>
                           <a:spcPts val="1960"/>
                         </a:lnSpc>
@@ -7583,7 +7651,7 @@
                       </a:endParaRPr>
                     </a:p>
                   </a:txBody>
-                  <a:tcPr marL="62230" marR="62230" marT="62230" marB="62230" anchor="t">
+                  <a:tcPr marL="62230" marR="62230" marT="62230" marB="62230">
                     <a:lnL w="12700" cap="flat" cmpd="sng" algn="ctr">
                       <a:solidFill>
                         <a:srgbClr val="C5C4C1"/>
@@ -7622,6 +7690,11 @@
                     </a:lnB>
                   </a:tcPr>
                 </a:tc>
+                <a:extLst>
+                  <a:ext uri="{0D108BD9-81ED-4DB2-BD59-A6C34878D82A}">
+                    <a16:rowId xmlns:a16="http://schemas.microsoft.com/office/drawing/2014/main" val="10003"/>
+                  </a:ext>
+                </a:extLst>
               </a:tr>
               <a:tr h="385961">
                 <a:tc>
@@ -7629,7 +7702,7 @@
                     <a:bodyPr/>
                     <a:lstStyle/>
                     <a:p>
-                      <a:pPr indent="0" marL="0">
+                      <a:pPr marL="0" indent="0">
                         <a:lnSpc>
                           <a:spcPts val="1960"/>
                         </a:lnSpc>
@@ -7653,7 +7726,7 @@
                       </a:endParaRPr>
                     </a:p>
                   </a:txBody>
-                  <a:tcPr marL="62230" marR="62230" marT="62230" marB="62230" anchor="t">
+                  <a:tcPr marL="62230" marR="62230" marT="62230" marB="62230">
                     <a:lnL w="12700" cap="flat" cmpd="sng" algn="ctr">
                       <a:solidFill>
                         <a:srgbClr val="C5C4C1"/>
@@ -7700,7 +7773,7 @@
                     <a:bodyPr/>
                     <a:lstStyle/>
                     <a:p>
-                      <a:pPr algn="r" indent="0" marL="0">
+                      <a:pPr marL="0" indent="0" algn="r">
                         <a:lnSpc>
                           <a:spcPts val="1960"/>
                         </a:lnSpc>
@@ -7724,7 +7797,7 @@
                       </a:endParaRPr>
                     </a:p>
                   </a:txBody>
-                  <a:tcPr marL="62230" marR="62230" marT="62230" marB="62230" anchor="t">
+                  <a:tcPr marL="62230" marR="62230" marT="62230" marB="62230">
                     <a:lnL w="12700" cap="flat" cmpd="sng" algn="ctr">
                       <a:solidFill>
                         <a:srgbClr val="C9B9AB"/>
@@ -7771,7 +7844,7 @@
                     <a:bodyPr/>
                     <a:lstStyle/>
                     <a:p>
-                      <a:pPr algn="r" indent="0" marL="0">
+                      <a:pPr marL="0" indent="0" algn="r">
                         <a:lnSpc>
                           <a:spcPts val="1960"/>
                         </a:lnSpc>
@@ -7795,7 +7868,7 @@
                       </a:endParaRPr>
                     </a:p>
                   </a:txBody>
-                  <a:tcPr marL="62230" marR="62230" marT="62230" marB="62230" anchor="t">
+                  <a:tcPr marL="62230" marR="62230" marT="62230" marB="62230">
                     <a:lnL w="12700" cap="flat" cmpd="sng" algn="ctr">
                       <a:solidFill>
                         <a:srgbClr val="C9B9AB"/>
@@ -7837,6 +7910,11 @@
                     </a:solidFill>
                   </a:tcPr>
                 </a:tc>
+                <a:extLst>
+                  <a:ext uri="{0D108BD9-81ED-4DB2-BD59-A6C34878D82A}">
+                    <a16:rowId xmlns:a16="http://schemas.microsoft.com/office/drawing/2014/main" val="10004"/>
+                  </a:ext>
+                </a:extLst>
               </a:tr>
             </a:tbl>
           </a:graphicData>
@@ -7865,7 +7943,7 @@
           </a:bodyPr>
           <a:lstStyle/>
           <a:p>
-            <a:pPr algn="l" indent="0" marL="0">
+            <a:pPr marL="0" indent="0" algn="l">
               <a:lnSpc>
                 <a:spcPts val="3600"/>
               </a:lnSpc>
@@ -7909,7 +7987,7 @@
           </a:bodyPr>
           <a:lstStyle/>
           <a:p>
-            <a:pPr algn="l" indent="0" marL="0">
+            <a:pPr marL="0" indent="0" algn="l">
               <a:lnSpc>
                 <a:spcPts val="1820"/>
               </a:lnSpc>
@@ -7953,7 +8031,7 @@
           </a:bodyPr>
           <a:lstStyle/>
           <a:p>
-            <a:pPr algn="l" indent="0" marL="0">
+            <a:pPr marL="0" indent="0" algn="l">
               <a:lnSpc>
                 <a:spcPts val="3600"/>
               </a:lnSpc>
@@ -7997,7 +8075,7 @@
           </a:bodyPr>
           <a:lstStyle/>
           <a:p>
-            <a:pPr algn="l" indent="0" marL="0">
+            <a:pPr marL="0" indent="0" algn="l">
               <a:lnSpc>
                 <a:spcPts val="1820"/>
               </a:lnSpc>
@@ -8041,7 +8119,7 @@
           </a:bodyPr>
           <a:lstStyle/>
           <a:p>
-            <a:pPr algn="l" indent="0" marL="0">
+            <a:pPr marL="0" indent="0" algn="l">
               <a:lnSpc>
                 <a:spcPts val="1960"/>
               </a:lnSpc>
@@ -8085,7 +8163,7 @@
           </a:bodyPr>
           <a:lstStyle/>
           <a:p>
-            <a:pPr algn="l" indent="0" marL="0">
+            <a:pPr marL="0" indent="0" algn="l">
               <a:lnSpc>
                 <a:spcPts val="1680"/>
               </a:lnSpc>
@@ -8402,4 +8480,319 @@
   <a:objectDefaults/>
   <a:extraClrSchemeLst/>
 </a:theme>
+</file>
+
+<file path=ppt/theme/theme2.xml><?xml version="1.0" encoding="utf-8"?>
+<a:theme xmlns:a="http://schemas.openxmlformats.org/drawingml/2006/main" name="Tema de Office">
+  <a:themeElements>
+    <a:clrScheme name="Office">
+      <a:dk1>
+        <a:sysClr val="windowText" lastClr="000000"/>
+      </a:dk1>
+      <a:lt1>
+        <a:sysClr val="window" lastClr="FFFFFF"/>
+      </a:lt1>
+      <a:dk2>
+        <a:srgbClr val="0E2841"/>
+      </a:dk2>
+      <a:lt2>
+        <a:srgbClr val="E8E8E8"/>
+      </a:lt2>
+      <a:accent1>
+        <a:srgbClr val="156082"/>
+      </a:accent1>
+      <a:accent2>
+        <a:srgbClr val="E97132"/>
+      </a:accent2>
+      <a:accent3>
+        <a:srgbClr val="196B24"/>
+      </a:accent3>
+      <a:accent4>
+        <a:srgbClr val="0F9ED5"/>
+      </a:accent4>
+      <a:accent5>
+        <a:srgbClr val="A02B93"/>
+      </a:accent5>
+      <a:accent6>
+        <a:srgbClr val="4EA72E"/>
+      </a:accent6>
+      <a:hlink>
+        <a:srgbClr val="467886"/>
+      </a:hlink>
+      <a:folHlink>
+        <a:srgbClr val="96607D"/>
+      </a:folHlink>
+    </a:clrScheme>
+    <a:fontScheme name="Office">
+      <a:majorFont>
+        <a:latin typeface="Aptos Display" panose="02110004020202020204"/>
+        <a:ea typeface=""/>
+        <a:cs typeface=""/>
+        <a:font script="Jpan" typeface="游ゴシック Light"/>
+        <a:font script="Hang" typeface="맑은 고딕"/>
+        <a:font script="Hans" typeface="等线 Light"/>
+        <a:font script="Hant" typeface="新細明體"/>
+        <a:font script="Arab" typeface="Times New Roman"/>
+        <a:font script="Hebr" typeface="Times New Roman"/>
+        <a:font script="Thai" typeface="Angsana New"/>
+        <a:font script="Ethi" typeface="Nyala"/>
+        <a:font script="Beng" typeface="Vrinda"/>
+        <a:font script="Gujr" typeface="Shruti"/>
+        <a:font script="Khmr" typeface="MoolBoran"/>
+        <a:font script="Knda" typeface="Tunga"/>
+        <a:font script="Guru" typeface="Raavi"/>
+        <a:font script="Cans" typeface="Euphemia"/>
+        <a:font script="Cher" typeface="Plantagenet Cherokee"/>
+        <a:font script="Yiii" typeface="Microsoft Yi Baiti"/>
+        <a:font script="Tibt" typeface="Microsoft Himalaya"/>
+        <a:font script="Thaa" typeface="MV Boli"/>
+        <a:font script="Deva" typeface="Mangal"/>
+        <a:font script="Telu" typeface="Gautami"/>
+        <a:font script="Taml" typeface="Latha"/>
+        <a:font script="Syrc" typeface="Estrangelo Edessa"/>
+        <a:font script="Orya" typeface="Kalinga"/>
+        <a:font script="Mlym" typeface="Kartika"/>
+        <a:font script="Laoo" typeface="DokChampa"/>
+        <a:font script="Sinh" typeface="Iskoola Pota"/>
+        <a:font script="Mong" typeface="Mongolian Baiti"/>
+        <a:font script="Viet" typeface="Times New Roman"/>
+        <a:font script="Uigh" typeface="Microsoft Uighur"/>
+        <a:font script="Geor" typeface="Sylfaen"/>
+        <a:font script="Armn" typeface="Arial"/>
+        <a:font script="Bugi" typeface="Leelawadee UI"/>
+        <a:font script="Bopo" typeface="Microsoft JhengHei"/>
+        <a:font script="Java" typeface="Javanese Text"/>
+        <a:font script="Lisu" typeface="Segoe UI"/>
+        <a:font script="Mymr" typeface="Myanmar Text"/>
+        <a:font script="Nkoo" typeface="Ebrima"/>
+        <a:font script="Olck" typeface="Nirmala UI"/>
+        <a:font script="Osma" typeface="Ebrima"/>
+        <a:font script="Phag" typeface="Phagspa"/>
+        <a:font script="Syrn" typeface="Estrangelo Edessa"/>
+        <a:font script="Syrj" typeface="Estrangelo Edessa"/>
+        <a:font script="Syre" typeface="Estrangelo Edessa"/>
+        <a:font script="Sora" typeface="Nirmala UI"/>
+        <a:font script="Tale" typeface="Microsoft Tai Le"/>
+        <a:font script="Talu" typeface="Microsoft New Tai Lue"/>
+        <a:font script="Tfng" typeface="Ebrima"/>
+      </a:majorFont>
+      <a:minorFont>
+        <a:latin typeface="Aptos" panose="02110004020202020204"/>
+        <a:ea typeface=""/>
+        <a:cs typeface=""/>
+        <a:font script="Jpan" typeface="游ゴシック"/>
+        <a:font script="Hang" typeface="맑은 고딕"/>
+        <a:font script="Hans" typeface="等线"/>
+        <a:font script="Hant" typeface="新細明體"/>
+        <a:font script="Arab" typeface="Arial"/>
+        <a:font script="Hebr" typeface="Arial"/>
+        <a:font script="Thai" typeface="Cordia New"/>
+        <a:font script="Ethi" typeface="Nyala"/>
+        <a:font script="Beng" typeface="Vrinda"/>
+        <a:font script="Gujr" typeface="Shruti"/>
+        <a:font script="Khmr" typeface="DaunPenh"/>
+        <a:font script="Knda" typeface="Tunga"/>
+        <a:font script="Guru" typeface="Raavi"/>
+        <a:font script="Cans" typeface="Euphemia"/>
+        <a:font script="Cher" typeface="Plantagenet Cherokee"/>
+        <a:font script="Yiii" typeface="Microsoft Yi Baiti"/>
+        <a:font script="Tibt" typeface="Microsoft Himalaya"/>
+        <a:font script="Thaa" typeface="MV Boli"/>
+        <a:font script="Deva" typeface="Mangal"/>
+        <a:font script="Telu" typeface="Gautami"/>
+        <a:font script="Taml" typeface="Latha"/>
+        <a:font script="Syrc" typeface="Estrangelo Edessa"/>
+        <a:font script="Orya" typeface="Kalinga"/>
+        <a:font script="Mlym" typeface="Kartika"/>
+        <a:font script="Laoo" typeface="DokChampa"/>
+        <a:font script="Sinh" typeface="Iskoola Pota"/>
+        <a:font script="Mong" typeface="Mongolian Baiti"/>
+        <a:font script="Viet" typeface="Arial"/>
+        <a:font script="Uigh" typeface="Microsoft Uighur"/>
+        <a:font script="Geor" typeface="Sylfaen"/>
+        <a:font script="Armn" typeface="Arial"/>
+        <a:font script="Bugi" typeface="Leelawadee UI"/>
+        <a:font script="Bopo" typeface="Microsoft JhengHei"/>
+        <a:font script="Java" typeface="Javanese Text"/>
+        <a:font script="Lisu" typeface="Segoe UI"/>
+        <a:font script="Mymr" typeface="Myanmar Text"/>
+        <a:font script="Nkoo" typeface="Ebrima"/>
+        <a:font script="Olck" typeface="Nirmala UI"/>
+        <a:font script="Osma" typeface="Ebrima"/>
+        <a:font script="Phag" typeface="Phagspa"/>
+        <a:font script="Syrn" typeface="Estrangelo Edessa"/>
+        <a:font script="Syrj" typeface="Estrangelo Edessa"/>
+        <a:font script="Syre" typeface="Estrangelo Edessa"/>
+        <a:font script="Sora" typeface="Nirmala UI"/>
+        <a:font script="Tale" typeface="Microsoft Tai Le"/>
+        <a:font script="Talu" typeface="Microsoft New Tai Lue"/>
+        <a:font script="Tfng" typeface="Ebrima"/>
+      </a:minorFont>
+    </a:fontScheme>
+    <a:fmtScheme name="Office">
+      <a:fillStyleLst>
+        <a:solidFill>
+          <a:schemeClr val="phClr"/>
+        </a:solidFill>
+        <a:gradFill rotWithShape="1">
+          <a:gsLst>
+            <a:gs pos="0">
+              <a:schemeClr val="phClr">
+                <a:lumMod val="110000"/>
+                <a:satMod val="105000"/>
+                <a:tint val="67000"/>
+              </a:schemeClr>
+            </a:gs>
+            <a:gs pos="50000">
+              <a:schemeClr val="phClr">
+                <a:lumMod val="105000"/>
+                <a:satMod val="103000"/>
+                <a:tint val="73000"/>
+              </a:schemeClr>
+            </a:gs>
+            <a:gs pos="100000">
+              <a:schemeClr val="phClr">
+                <a:lumMod val="105000"/>
+                <a:satMod val="109000"/>
+                <a:tint val="81000"/>
+              </a:schemeClr>
+            </a:gs>
+          </a:gsLst>
+          <a:lin ang="5400000" scaled="0"/>
+        </a:gradFill>
+        <a:gradFill rotWithShape="1">
+          <a:gsLst>
+            <a:gs pos="0">
+              <a:schemeClr val="phClr">
+                <a:satMod val="103000"/>
+                <a:lumMod val="102000"/>
+                <a:tint val="94000"/>
+              </a:schemeClr>
+            </a:gs>
+            <a:gs pos="50000">
+              <a:schemeClr val="phClr">
+                <a:satMod val="110000"/>
+                <a:lumMod val="100000"/>
+                <a:shade val="100000"/>
+              </a:schemeClr>
+            </a:gs>
+            <a:gs pos="100000">
+              <a:schemeClr val="phClr">
+                <a:lumMod val="99000"/>
+                <a:satMod val="120000"/>
+                <a:shade val="78000"/>
+              </a:schemeClr>
+            </a:gs>
+          </a:gsLst>
+          <a:lin ang="5400000" scaled="0"/>
+        </a:gradFill>
+      </a:fillStyleLst>
+      <a:lnStyleLst>
+        <a:ln w="12700" cap="flat" cmpd="sng" algn="ctr">
+          <a:solidFill>
+            <a:schemeClr val="phClr"/>
+          </a:solidFill>
+          <a:prstDash val="solid"/>
+          <a:miter lim="800000"/>
+        </a:ln>
+        <a:ln w="19050" cap="flat" cmpd="sng" algn="ctr">
+          <a:solidFill>
+            <a:schemeClr val="phClr"/>
+          </a:solidFill>
+          <a:prstDash val="solid"/>
+          <a:miter lim="800000"/>
+        </a:ln>
+        <a:ln w="25400" cap="flat" cmpd="sng" algn="ctr">
+          <a:solidFill>
+            <a:schemeClr val="phClr"/>
+          </a:solidFill>
+          <a:prstDash val="solid"/>
+          <a:miter lim="800000"/>
+        </a:ln>
+      </a:lnStyleLst>
+      <a:effectStyleLst>
+        <a:effectStyle>
+          <a:effectLst/>
+        </a:effectStyle>
+        <a:effectStyle>
+          <a:effectLst/>
+        </a:effectStyle>
+        <a:effectStyle>
+          <a:effectLst>
+            <a:outerShdw blurRad="57150" dist="19050" dir="5400000" algn="ctr" rotWithShape="0">
+              <a:srgbClr val="000000">
+                <a:alpha val="63000"/>
+              </a:srgbClr>
+            </a:outerShdw>
+          </a:effectLst>
+        </a:effectStyle>
+      </a:effectStyleLst>
+      <a:bgFillStyleLst>
+        <a:solidFill>
+          <a:schemeClr val="phClr"/>
+        </a:solidFill>
+        <a:solidFill>
+          <a:schemeClr val="phClr">
+            <a:tint val="95000"/>
+            <a:satMod val="170000"/>
+          </a:schemeClr>
+        </a:solidFill>
+        <a:gradFill rotWithShape="1">
+          <a:gsLst>
+            <a:gs pos="0">
+              <a:schemeClr val="phClr">
+                <a:tint val="93000"/>
+                <a:satMod val="150000"/>
+                <a:shade val="98000"/>
+                <a:lumMod val="102000"/>
+              </a:schemeClr>
+            </a:gs>
+            <a:gs pos="50000">
+              <a:schemeClr val="phClr">
+                <a:tint val="98000"/>
+                <a:satMod val="130000"/>
+                <a:shade val="90000"/>
+                <a:lumMod val="103000"/>
+              </a:schemeClr>
+            </a:gs>
+            <a:gs pos="100000">
+              <a:schemeClr val="phClr">
+                <a:shade val="63000"/>
+                <a:satMod val="120000"/>
+              </a:schemeClr>
+            </a:gs>
+          </a:gsLst>
+          <a:lin ang="5400000" scaled="0"/>
+        </a:gradFill>
+      </a:bgFillStyleLst>
+    </a:fmtScheme>
+  </a:themeElements>
+  <a:objectDefaults>
+    <a:lnDef>
+      <a:spPr/>
+      <a:bodyPr/>
+      <a:lstStyle/>
+      <a:style>
+        <a:lnRef idx="2">
+          <a:schemeClr val="accent1"/>
+        </a:lnRef>
+        <a:fillRef idx="0">
+          <a:schemeClr val="accent1"/>
+        </a:fillRef>
+        <a:effectRef idx="1">
+          <a:schemeClr val="accent1"/>
+        </a:effectRef>
+        <a:fontRef idx="minor">
+          <a:schemeClr val="tx1"/>
+        </a:fontRef>
+      </a:style>
+    </a:lnDef>
+  </a:objectDefaults>
+  <a:extraClrSchemeLst/>
+  <a:extLst>
+    <a:ext uri="{05A4C25C-085E-4340-85A3-A5531E510DB2}">
+      <thm15:themeFamily xmlns:thm15="http://schemas.microsoft.com/office/thememl/2012/main" name="Office Theme" id="{2E142A2C-CD16-42D6-873A-C26D2A0506FA}" vid="{1BDDFF52-6CD6-40A5-AB3C-68EB2F1E4D0A}"/>
+    </a:ext>
+  </a:extLst>
+</a:theme>
 </file>
</xml_diff>